<commit_message>
Updated PPT with team details and fixed architecture image
</commit_message>
<xml_diff>
--- a/StrumSense_Build_with_Bharat_2.0.pptx
+++ b/StrumSense_Build_with_Bharat_2.0.pptx
@@ -4,6 +4,9 @@
   <p:sldMasterIdLst>
     <p:sldMasterId id="2147483648" r:id="rId1"/>
   </p:sldMasterIdLst>
+  <p:notesMasterIdLst>
+    <p:notesMasterId r:id="rId10"/>
+  </p:notesMasterIdLst>
   <p:sldIdLst>
     <p:sldId id="256" r:id="rId2"/>
     <p:sldId id="257" r:id="rId3"/>
@@ -14,9 +17,6 @@
     <p:sldId id="262" r:id="rId8"/>
     <p:sldId id="263" r:id="rId9"/>
   </p:sldIdLst>
-  <p:notesMasterIdLst>
-    <p:notesMasterId r:id="rId10"/>
-  </p:notesMasterIdLst>
   <p:sldSz cx="12192000" cy="6858000"/>
   <p:notesSz cx="6858000" cy="12192000"/>
   <p:defaultTextStyle>
@@ -111,7 +111,111 @@
       </a:defRPr>
     </a:lvl9pPr>
   </p:defaultTextStyle>
+  <p:extLst>
+    <p:ext uri="{EFAFB233-063F-42B5-8137-9DF3F51BA10A}">
+      <p15:sldGuideLst xmlns:p15="http://schemas.microsoft.com/office/powerpoint/2012/main"/>
+    </p:ext>
+  </p:extLst>
 </p:presentation>
+</file>
+
+<file path=ppt/revisionInfo.xml><?xml version="1.0" encoding="utf-8"?>
+<p1510:revInfo xmlns:a="http://schemas.openxmlformats.org/drawingml/2006/main" xmlns:r="http://schemas.openxmlformats.org/officeDocument/2006/relationships" xmlns:p1510="http://schemas.microsoft.com/office/powerpoint/2015/10/main">
+  <p1510:revLst>
+    <p1510:client id="{0B2C4BBF-9ACF-428D-8BFB-1B70B47D1A4F}" v="13" dt="2026-09-01T11:28:32.825"/>
+  </p1510:revLst>
+</p1510:revInfo>
+</file>
+
+<file path=ppt/changesInfos/changesInfo1.xml><?xml version="1.0" encoding="utf-8"?>
+<pc:chgInfo xmlns:a="http://schemas.openxmlformats.org/drawingml/2006/main" xmlns:r="http://schemas.openxmlformats.org/officeDocument/2006/relationships" xmlns:ac="http://schemas.microsoft.com/office/drawing/2013/main/command" xmlns:pc="http://schemas.microsoft.com/office/powerpoint/2013/main/command">
+  <pc:docChgLst>
+    <pc:chgData name="Aman Singh" userId="59ab53f7b0af5e8b" providerId="LiveId" clId="{9E36CD2A-74E6-40E8-A8E9-578E1CDB348B}"/>
+    <pc:docChg chg="undo custSel modSld">
+      <pc:chgData name="Aman Singh" userId="59ab53f7b0af5e8b" providerId="LiveId" clId="{9E36CD2A-74E6-40E8-A8E9-578E1CDB348B}" dt="2026-09-01T11:30:09.100" v="327" actId="20577"/>
+      <pc:docMkLst>
+        <pc:docMk/>
+      </pc:docMkLst>
+      <pc:sldChg chg="modSp mod">
+        <pc:chgData name="Aman Singh" userId="59ab53f7b0af5e8b" providerId="LiveId" clId="{9E36CD2A-74E6-40E8-A8E9-578E1CDB348B}" dt="2026-09-01T11:30:09.100" v="327" actId="20577"/>
+        <pc:sldMkLst>
+          <pc:docMk/>
+          <pc:sldMk cId="0" sldId="256"/>
+        </pc:sldMkLst>
+        <pc:spChg chg="mod">
+          <ac:chgData name="Aman Singh" userId="59ab53f7b0af5e8b" providerId="LiveId" clId="{9E36CD2A-74E6-40E8-A8E9-578E1CDB348B}" dt="2026-09-01T11:28:00.722" v="252" actId="113"/>
+          <ac:spMkLst>
+            <pc:docMk/>
+            <pc:sldMk cId="0" sldId="256"/>
+            <ac:spMk id="13" creationId="{00000000-0000-0000-0000-000000000000}"/>
+          </ac:spMkLst>
+        </pc:spChg>
+        <pc:spChg chg="mod">
+          <ac:chgData name="Aman Singh" userId="59ab53f7b0af5e8b" providerId="LiveId" clId="{9E36CD2A-74E6-40E8-A8E9-578E1CDB348B}" dt="2026-09-01T11:30:09.100" v="327" actId="20577"/>
+          <ac:spMkLst>
+            <pc:docMk/>
+            <pc:sldMk cId="0" sldId="256"/>
+            <ac:spMk id="15" creationId="{00000000-0000-0000-0000-000000000000}"/>
+          </ac:spMkLst>
+        </pc:spChg>
+        <pc:spChg chg="mod">
+          <ac:chgData name="Aman Singh" userId="59ab53f7b0af5e8b" providerId="LiveId" clId="{9E36CD2A-74E6-40E8-A8E9-578E1CDB348B}" dt="2026-09-01T11:28:54.338" v="325" actId="113"/>
+          <ac:spMkLst>
+            <pc:docMk/>
+            <pc:sldMk cId="0" sldId="256"/>
+            <ac:spMk id="16" creationId="{00000000-0000-0000-0000-000000000000}"/>
+          </ac:spMkLst>
+        </pc:spChg>
+      </pc:sldChg>
+      <pc:sldChg chg="modSp mod">
+        <pc:chgData name="Aman Singh" userId="59ab53f7b0af5e8b" providerId="LiveId" clId="{9E36CD2A-74E6-40E8-A8E9-578E1CDB348B}" dt="2026-08-29T05:16:14.195" v="91" actId="20577"/>
+        <pc:sldMkLst>
+          <pc:docMk/>
+          <pc:sldMk cId="0" sldId="259"/>
+        </pc:sldMkLst>
+        <pc:spChg chg="mod">
+          <ac:chgData name="Aman Singh" userId="59ab53f7b0af5e8b" providerId="LiveId" clId="{9E36CD2A-74E6-40E8-A8E9-578E1CDB348B}" dt="2026-08-29T05:16:14.195" v="91" actId="20577"/>
+          <ac:spMkLst>
+            <pc:docMk/>
+            <pc:sldMk cId="0" sldId="259"/>
+            <ac:spMk id="39" creationId="{00000000-0000-0000-0000-000000000000}"/>
+          </ac:spMkLst>
+        </pc:spChg>
+      </pc:sldChg>
+      <pc:sldChg chg="addSp delSp modSp mod">
+        <pc:chgData name="Aman Singh" userId="59ab53f7b0af5e8b" providerId="LiveId" clId="{9E36CD2A-74E6-40E8-A8E9-578E1CDB348B}" dt="2026-08-29T05:29:40.957" v="99" actId="20577"/>
+        <pc:sldMkLst>
+          <pc:docMk/>
+          <pc:sldMk cId="0" sldId="263"/>
+        </pc:sldMkLst>
+        <pc:spChg chg="add del mod">
+          <ac:chgData name="Aman Singh" userId="59ab53f7b0af5e8b" providerId="LiveId" clId="{9E36CD2A-74E6-40E8-A8E9-578E1CDB348B}" dt="2026-08-29T05:29:40.957" v="99" actId="20577"/>
+          <ac:spMkLst>
+            <pc:docMk/>
+            <pc:sldMk cId="0" sldId="263"/>
+            <ac:spMk id="15" creationId="{00000000-0000-0000-0000-000000000000}"/>
+          </ac:spMkLst>
+        </pc:spChg>
+        <pc:spChg chg="add mod">
+          <ac:chgData name="Aman Singh" userId="59ab53f7b0af5e8b" providerId="LiveId" clId="{9E36CD2A-74E6-40E8-A8E9-578E1CDB348B}" dt="2026-08-29T05:06:25.130" v="58" actId="1076"/>
+          <ac:spMkLst>
+            <pc:docMk/>
+            <pc:sldMk cId="0" sldId="263"/>
+            <ac:spMk id="21" creationId="{1D0E17CE-03C1-56C2-A3AD-7B9BC9DFEF5A}"/>
+          </ac:spMkLst>
+        </pc:spChg>
+        <pc:picChg chg="add mod">
+          <ac:chgData name="Aman Singh" userId="59ab53f7b0af5e8b" providerId="LiveId" clId="{9E36CD2A-74E6-40E8-A8E9-578E1CDB348B}" dt="2026-08-29T05:02:03.886" v="21" actId="1076"/>
+          <ac:picMkLst>
+            <pc:docMk/>
+            <pc:sldMk cId="0" sldId="263"/>
+            <ac:picMk id="20" creationId="{D6899AFB-00CC-1DF5-6B17-56C07E1147BE}"/>
+          </ac:picMkLst>
+        </pc:picChg>
+      </pc:sldChg>
+    </pc:docChg>
+  </pc:docChgLst>
+</pc:chgInfo>
 </file>
 
 <file path=ppt/notesMasters/notesMaster1.xml><?xml version="1.0" encoding="utf-8"?>
@@ -136,234 +240,10 @@
           <a:chExt cx="0" cy="0"/>
         </a:xfrm>
       </p:grpSpPr>
-      <p:sp>
-        <p:nvSpPr>
-          <p:cNvPr id="2" name="Header Placeholder 1"/>
-          <p:cNvSpPr>
-            <a:spLocks noGrp="1"/>
-          </p:cNvSpPr>
-          <p:nvPr>
-            <p:ph type="hdr" sz="quarter"/>
-          </p:nvPr>
-        </p:nvSpPr>
-        <p:spPr>
-          <a:xfrm>
-            <a:off x="0" y="0"/>
-            <a:ext cx="2971800" cy="458788"/>
-          </a:xfrm>
-          <a:prstGeom prst="rect">
-            <a:avLst/>
-          </a:prstGeom>
-        </p:spPr>
-        <p:txBody>
-          <a:bodyPr vert="horz" lIns="91440" tIns="45720" rIns="91440" bIns="45720" rtlCol="0"/>
-          <a:lstStyle>
-            <a:lvl1pPr algn="l">
-              <a:defRPr sz="1200"/>
-            </a:lvl1pPr>
-          </a:lstStyle>
-          <a:p>
-            <a:endParaRPr lang="en-US"/>
-          </a:p>
-        </p:txBody>
-      </p:sp>
-      <p:sp>
-        <p:nvSpPr>
-          <p:cNvPr id="3" name="Date Placeholder 2"/>
-          <p:cNvSpPr>
-            <a:spLocks noGrp="1"/>
-          </p:cNvSpPr>
-          <p:nvPr>
-            <p:ph type="dt" idx="1"/>
-          </p:nvPr>
-        </p:nvSpPr>
-        <p:spPr>
-          <a:xfrm>
-            <a:off x="3884613" y="0"/>
-            <a:ext cx="2971800" cy="458788"/>
-          </a:xfrm>
-          <a:prstGeom prst="rect">
-            <a:avLst/>
-          </a:prstGeom>
-        </p:spPr>
-        <p:txBody>
-          <a:bodyPr vert="horz" lIns="91440" tIns="45720" rIns="91440" bIns="45720" rtlCol="0"/>
-          <a:lstStyle>
-            <a:lvl1pPr algn="r">
-              <a:defRPr sz="1200"/>
-            </a:lvl1pPr>
-          </a:lstStyle>
-          <a:p>
-            <a:fld id="{5282F153-3F37-0F45-9E97-73ACFA13230C}" type="datetimeFigureOut">
-              <a:rPr lang="en-US"/>
-              <a:t>7/23/19</a:t>
-            </a:fld>
-            <a:endParaRPr lang="en-US"/>
-          </a:p>
-        </p:txBody>
-      </p:sp>
-      <p:sp>
-        <p:nvSpPr>
-          <p:cNvPr id="4" name="Slide Image Placeholder 3"/>
-          <p:cNvSpPr>
-            <a:spLocks noGrp="1" noRot="1" noChangeAspect="1"/>
-          </p:cNvSpPr>
-          <p:nvPr>
-            <p:ph type="sldImg" idx="2"/>
-          </p:nvPr>
-        </p:nvSpPr>
-        <p:spPr>
-          <a:xfrm>
-            <a:off x="685800" y="1143000"/>
-            <a:ext cx="5486400" cy="3086100"/>
-          </a:xfrm>
-          <a:prstGeom prst="rect">
-            <a:avLst/>
-          </a:prstGeom>
-          <a:noFill/>
-          <a:ln w="12700">
-            <a:solidFill>
-              <a:prstClr val="black"/>
-            </a:solidFill>
-          </a:ln>
-        </p:spPr>
-        <p:txBody>
-          <a:bodyPr vert="horz" lIns="91440" tIns="45720" rIns="91440" bIns="45720" rtlCol="0" anchor="ctr"/>
-          <a:lstStyle/>
-          <a:p>
-            <a:endParaRPr lang="en-US"/>
-          </a:p>
-        </p:txBody>
-      </p:sp>
-      <p:sp>
-        <p:nvSpPr>
-          <p:cNvPr id="5" name="Notes Placeholder 4"/>
-          <p:cNvSpPr>
-            <a:spLocks noGrp="1"/>
-          </p:cNvSpPr>
-          <p:nvPr>
-            <p:ph type="body" sz="quarter" idx="3"/>
-          </p:nvPr>
-        </p:nvSpPr>
-        <p:spPr>
-          <a:xfrm>
-            <a:off x="685800" y="4400550"/>
-            <a:ext cx="5486400" cy="3600450"/>
-          </a:xfrm>
-          <a:prstGeom prst="rect">
-            <a:avLst/>
-          </a:prstGeom>
-        </p:spPr>
-        <p:txBody>
-          <a:bodyPr vert="horz" lIns="91440" tIns="45720" rIns="91440" bIns="45720" rtlCol="0"/>
-          <a:lstStyle/>
-          <a:p>
-            <a:pPr lvl="0"/>
-            <a:r>
-              <a:rPr lang="en-US"/>
-              <a:t>Click to edit Master text styles</a:t>
-            </a:r>
-          </a:p>
-          <a:p>
-            <a:pPr lvl="1"/>
-            <a:r>
-              <a:rPr lang="en-US"/>
-              <a:t>Second level</a:t>
-            </a:r>
-          </a:p>
-          <a:p>
-            <a:pPr lvl="2"/>
-            <a:r>
-              <a:rPr lang="en-US"/>
-              <a:t>Third level</a:t>
-            </a:r>
-          </a:p>
-          <a:p>
-            <a:pPr lvl="3"/>
-            <a:r>
-              <a:rPr lang="en-US"/>
-              <a:t>Fourth level</a:t>
-            </a:r>
-          </a:p>
-          <a:p>
-            <a:pPr lvl="4"/>
-            <a:r>
-              <a:rPr lang="en-US"/>
-              <a:t>Fifth level</a:t>
-            </a:r>
-          </a:p>
-        </p:txBody>
-      </p:sp>
-      <p:sp>
-        <p:nvSpPr>
-          <p:cNvPr id="6" name="Footer Placeholder 5"/>
-          <p:cNvSpPr>
-            <a:spLocks noGrp="1"/>
-          </p:cNvSpPr>
-          <p:nvPr>
-            <p:ph type="ftr" sz="quarter" idx="4"/>
-          </p:nvPr>
-        </p:nvSpPr>
-        <p:spPr>
-          <a:xfrm>
-            <a:off x="0" y="8685213"/>
-            <a:ext cx="2971800" cy="458787"/>
-          </a:xfrm>
-          <a:prstGeom prst="rect">
-            <a:avLst/>
-          </a:prstGeom>
-        </p:spPr>
-        <p:txBody>
-          <a:bodyPr vert="horz" lIns="91440" tIns="45720" rIns="91440" bIns="45720" rtlCol="0" anchor="b"/>
-          <a:lstStyle>
-            <a:lvl1pPr algn="l">
-              <a:defRPr sz="1200"/>
-            </a:lvl1pPr>
-          </a:lstStyle>
-          <a:p>
-            <a:endParaRPr lang="en-US"/>
-          </a:p>
-        </p:txBody>
-      </p:sp>
-      <p:sp>
-        <p:nvSpPr>
-          <p:cNvPr id="7" name="Slide Number Placeholder 6"/>
-          <p:cNvSpPr>
-            <a:spLocks noGrp="1"/>
-          </p:cNvSpPr>
-          <p:nvPr>
-            <p:ph type="sldNum" sz="quarter" idx="5"/>
-          </p:nvPr>
-        </p:nvSpPr>
-        <p:spPr>
-          <a:xfrm>
-            <a:off x="3884613" y="8685213"/>
-            <a:ext cx="2971800" cy="458787"/>
-          </a:xfrm>
-          <a:prstGeom prst="rect">
-            <a:avLst/>
-          </a:prstGeom>
-        </p:spPr>
-        <p:txBody>
-          <a:bodyPr vert="horz" lIns="91440" tIns="45720" rIns="91440" bIns="45720" rtlCol="0" anchor="b"/>
-          <a:lstStyle>
-            <a:lvl1pPr algn="r">
-              <a:defRPr sz="1200"/>
-            </a:lvl1pPr>
-          </a:lstStyle>
-          <a:p>
-            <a:fld id="{CE5E9CC1-C706-0F49-92D6-E571CC5EEA8F}" type="slidenum">
-              <a:rPr lang="en-US"/>
-              <a:t>‹#›</a:t>
-            </a:fld>
-            <a:endParaRPr lang="en-US"/>
-          </a:p>
-        </p:txBody>
-      </p:sp>
     </p:spTree>
     <p:extLst>
       <p:ext uri="{BB962C8B-B14F-4D97-AF65-F5344CB8AC3E}">
-        <p14:creationId xmlns:p14="http://schemas.microsoft.com/office/powerpoint/2010/main" val="1024086991"/>
+        <p14:creationId xmlns:p14="http://schemas.microsoft.com/office/powerpoint/2010/main" val="747573326"/>
       </p:ext>
     </p:extLst>
   </p:cSld>
@@ -507,10 +387,6 @@
           <a:bodyPr/>
           <a:lstStyle/>
           <a:p>
-            <a:r>
-              <a:rPr lang="en-US" dirty="0"/>
-              <a:t/>
-            </a:r>
             <a:endParaRPr lang="en-US" dirty="0"/>
           </a:p>
         </p:txBody>
@@ -595,10 +471,6 @@
           <a:bodyPr/>
           <a:lstStyle/>
           <a:p>
-            <a:r>
-              <a:rPr lang="en-US" dirty="0"/>
-              <a:t/>
-            </a:r>
             <a:endParaRPr lang="en-US" dirty="0"/>
           </a:p>
         </p:txBody>
@@ -683,10 +555,6 @@
           <a:bodyPr/>
           <a:lstStyle/>
           <a:p>
-            <a:r>
-              <a:rPr lang="en-US" dirty="0"/>
-              <a:t/>
-            </a:r>
             <a:endParaRPr lang="en-US" dirty="0"/>
           </a:p>
         </p:txBody>
@@ -771,10 +639,6 @@
           <a:bodyPr/>
           <a:lstStyle/>
           <a:p>
-            <a:r>
-              <a:rPr lang="en-US" dirty="0"/>
-              <a:t/>
-            </a:r>
             <a:endParaRPr lang="en-US" dirty="0"/>
           </a:p>
         </p:txBody>
@@ -859,10 +723,6 @@
           <a:bodyPr/>
           <a:lstStyle/>
           <a:p>
-            <a:r>
-              <a:rPr lang="en-US" dirty="0"/>
-              <a:t/>
-            </a:r>
             <a:endParaRPr lang="en-US" dirty="0"/>
           </a:p>
         </p:txBody>
@@ -947,10 +807,6 @@
           <a:bodyPr/>
           <a:lstStyle/>
           <a:p>
-            <a:r>
-              <a:rPr lang="en-US" dirty="0"/>
-              <a:t/>
-            </a:r>
             <a:endParaRPr lang="en-US" dirty="0"/>
           </a:p>
         </p:txBody>
@@ -1035,10 +891,6 @@
           <a:bodyPr/>
           <a:lstStyle/>
           <a:p>
-            <a:r>
-              <a:rPr lang="en-US" dirty="0"/>
-              <a:t/>
-            </a:r>
             <a:endParaRPr lang="en-US" dirty="0"/>
           </a:p>
         </p:txBody>
@@ -1123,10 +975,6 @@
           <a:bodyPr/>
           <a:lstStyle/>
           <a:p>
-            <a:r>
-              <a:rPr lang="en-US" dirty="0"/>
-              <a:t/>
-            </a:r>
             <a:endParaRPr lang="en-US" dirty="0"/>
           </a:p>
         </p:txBody>
@@ -1200,6 +1048,11 @@
 <file path=ppt/slideMasters/slideMaster1.xml><?xml version="1.0" encoding="utf-8"?>
 <p:sldMaster xmlns:a="http://schemas.openxmlformats.org/drawingml/2006/main" xmlns:r="http://schemas.openxmlformats.org/officeDocument/2006/relationships" xmlns:p="http://schemas.openxmlformats.org/presentationml/2006/main">
   <p:cSld>
+    <p:bg>
+      <p:bgRef idx="1001">
+        <a:schemeClr val="bg1"/>
+      </p:bgRef>
+    </p:bg>
     <p:spTree>
       <p:nvGrpSpPr>
         <p:cNvPr id="1" name=""/>
@@ -1482,6 +1335,7 @@
         <a:solidFill>
           <a:srgbClr val="FFFFFF"/>
         </a:solidFill>
+        <a:effectLst/>
       </p:bgPr>
     </p:bg>
     <p:spTree>
@@ -1500,55 +1354,7 @@
       </p:grpSpPr>
       <p:pic>
         <p:nvPicPr>
-          <p:cNvPr id="2" name="Image 0" descr="/home/claude/work/assets/watermark.png">    </p:cNvPr>
-          <p:cNvPicPr>
-            <a:picLocks noChangeAspect="1"/>
-          </p:cNvPicPr>
-          <p:nvPr/>
-        </p:nvPicPr>
-        <p:blipFill>
-          <a:blip r:embed="rId1"/>
-          <a:stretch>
-            <a:fillRect/>
-          </a:stretch>
-        </p:blipFill>
-        <p:spPr>
-          <a:xfrm>
-            <a:off x="3566160" y="914400"/>
-            <a:ext cx="5029200" cy="5029200"/>
-          </a:xfrm>
-          <a:prstGeom prst="rect">
-            <a:avLst/>
-          </a:prstGeom>
-        </p:spPr>
-      </p:pic>
-      <p:pic>
-        <p:nvPicPr>
-          <p:cNvPr id="3" name="Image 1" descr="/home/claude/work/assets/logo_nit.jpeg">    </p:cNvPr>
-          <p:cNvPicPr>
-            <a:picLocks noChangeAspect="1"/>
-          </p:cNvPicPr>
-          <p:nvPr/>
-        </p:nvPicPr>
-        <p:blipFill>
-          <a:blip r:embed="rId2"/>
-          <a:stretch>
-            <a:fillRect/>
-          </a:stretch>
-        </p:blipFill>
-        <p:spPr>
-          <a:xfrm>
-            <a:off x="457200" y="256032"/>
-            <a:ext cx="822960" cy="822960"/>
-          </a:xfrm>
-          <a:prstGeom prst="rect">
-            <a:avLst/>
-          </a:prstGeom>
-        </p:spPr>
-      </p:pic>
-      <p:pic>
-        <p:nvPicPr>
-          <p:cNvPr id="4" name="Image 2" descr="/home/claude/work/assets/logo_codeverse.jpeg">    </p:cNvPr>
+          <p:cNvPr id="2" name="Image 0" descr="/home/claude/work/assets/watermark.png"/>
           <p:cNvPicPr>
             <a:picLocks noChangeAspect="1"/>
           </p:cNvPicPr>
@@ -1562,8 +1368,8 @@
         </p:blipFill>
         <p:spPr>
           <a:xfrm>
-            <a:off x="5367528" y="109728"/>
-            <a:ext cx="1463040" cy="1188720"/>
+            <a:off x="3566160" y="914400"/>
+            <a:ext cx="5029200" cy="5029200"/>
           </a:xfrm>
           <a:prstGeom prst="rect">
             <a:avLst/>
@@ -1572,7 +1378,7 @@
       </p:pic>
       <p:pic>
         <p:nvPicPr>
-          <p:cNvPr id="5" name="Image 3" descr="/home/claude/work/assets/logo_up.jpeg">    </p:cNvPr>
+          <p:cNvPr id="3" name="Image 1" descr="/home/claude/work/assets/logo_nit.jpeg"/>
           <p:cNvPicPr>
             <a:picLocks noChangeAspect="1"/>
           </p:cNvPicPr>
@@ -1586,6 +1392,54 @@
         </p:blipFill>
         <p:spPr>
           <a:xfrm>
+            <a:off x="457200" y="256032"/>
+            <a:ext cx="822960" cy="822960"/>
+          </a:xfrm>
+          <a:prstGeom prst="rect">
+            <a:avLst/>
+          </a:prstGeom>
+        </p:spPr>
+      </p:pic>
+      <p:pic>
+        <p:nvPicPr>
+          <p:cNvPr id="4" name="Image 2" descr="/home/claude/work/assets/logo_codeverse.jpeg"/>
+          <p:cNvPicPr>
+            <a:picLocks noChangeAspect="1"/>
+          </p:cNvPicPr>
+          <p:nvPr/>
+        </p:nvPicPr>
+        <p:blipFill>
+          <a:blip r:embed="rId5"/>
+          <a:stretch>
+            <a:fillRect/>
+          </a:stretch>
+        </p:blipFill>
+        <p:spPr>
+          <a:xfrm>
+            <a:off x="5367528" y="109728"/>
+            <a:ext cx="1463040" cy="1188720"/>
+          </a:xfrm>
+          <a:prstGeom prst="rect">
+            <a:avLst/>
+          </a:prstGeom>
+        </p:spPr>
+      </p:pic>
+      <p:pic>
+        <p:nvPicPr>
+          <p:cNvPr id="5" name="Image 3" descr="/home/claude/work/assets/logo_up.jpeg"/>
+          <p:cNvPicPr>
+            <a:picLocks noChangeAspect="1"/>
+          </p:cNvPicPr>
+          <p:nvPr/>
+        </p:nvPicPr>
+        <p:blipFill>
+          <a:blip r:embed="rId6"/>
+          <a:stretch>
+            <a:fillRect/>
+          </a:stretch>
+        </p:blipFill>
+        <p:spPr>
+          <a:xfrm>
             <a:off x="10927080" y="292608"/>
             <a:ext cx="777240" cy="777240"/>
           </a:xfrm>
@@ -1655,7 +1509,7 @@
           <a:bodyPr wrap="square" lIns="0" tIns="0" rIns="0" bIns="0" rtlCol="0" anchor="ctr"/>
           <a:lstStyle/>
           <a:p>
-            <a:pPr algn="ctr" indent="0" marL="0">
+            <a:pPr marL="0" indent="0" algn="ctr">
               <a:buNone/>
             </a:pPr>
             <a:r>
@@ -1669,9 +1523,6 @@
               </a:rPr>
               <a:t>BUILD WITH  </a:t>
             </a:r>
-            <a:pPr algn="ctr" indent="0" marL="0">
-              <a:buNone/>
-            </a:pPr>
             <a:r>
               <a:rPr lang="en-US" sz="1000" b="1" dirty="0">
                 <a:solidFill>
@@ -1708,7 +1559,7 @@
           <a:bodyPr wrap="square" lIns="0" tIns="0" rIns="0" bIns="0" rtlCol="0" anchor="ctr"/>
           <a:lstStyle/>
           <a:p>
-            <a:pPr algn="ctr" indent="0" marL="0">
+            <a:pPr marL="0" indent="0" algn="ctr">
               <a:buNone/>
             </a:pPr>
             <a:r>
@@ -1722,9 +1573,6 @@
               </a:rPr>
               <a:t>BUILD</a:t>
             </a:r>
-            <a:pPr algn="ctr" indent="0" marL="0">
-              <a:buNone/>
-            </a:pPr>
             <a:r>
               <a:rPr lang="en-US" sz="2600" b="1" dirty="0">
                 <a:solidFill>
@@ -1761,7 +1609,7 @@
           <a:bodyPr wrap="square" lIns="0" tIns="0" rIns="0" bIns="0" rtlCol="0" anchor="ctr"/>
           <a:lstStyle/>
           <a:p>
-            <a:pPr algn="ctr" indent="0" marL="0">
+            <a:pPr marL="0" indent="0" algn="ctr">
               <a:buNone/>
             </a:pPr>
             <a:r>
@@ -1800,11 +1648,11 @@
           <a:bodyPr wrap="square" lIns="0" tIns="0" rIns="0" bIns="0" rtlCol="0" anchor="ctr"/>
           <a:lstStyle/>
           <a:p>
-            <a:pPr algn="ctr" indent="0" marL="0">
+            <a:pPr marL="0" indent="0" algn="ctr">
               <a:buNone/>
             </a:pPr>
             <a:r>
-              <a:rPr lang="en-US" sz="1500" b="1" spc="300" kern="0" dirty="0">
+              <a:rPr lang="en-US" sz="1500" b="1" kern="0" spc="300" dirty="0">
                 <a:solidFill>
                   <a:srgbClr val="1A1A1A"/>
                 </a:solidFill>
@@ -1859,7 +1707,7 @@
           <a:bodyPr wrap="square" lIns="0" tIns="0" rIns="0" bIns="0" rtlCol="0" anchor="ctr"/>
           <a:lstStyle/>
           <a:p>
-            <a:pPr indent="0" marL="0">
+            <a:pPr marL="0" indent="0">
               <a:buNone/>
             </a:pPr>
             <a:r>
@@ -1873,9 +1721,6 @@
               </a:rPr>
               <a:t>TEAM NAME:  </a:t>
             </a:r>
-            <a:pPr indent="0" marL="0">
-              <a:buNone/>
-            </a:pPr>
             <a:r>
               <a:rPr lang="en-US" sz="1400" dirty="0">
                 <a:solidFill>
@@ -1885,7 +1730,18 @@
                 <a:ea typeface="Arial" pitchFamily="34" charset="-122"/>
                 <a:cs typeface="Arial" pitchFamily="34" charset="-120"/>
               </a:rPr>
-              <a:t>CodeVerse Innovators  [edit as needed]</a:t>
+              <a:t>The </a:t>
+            </a:r>
+            <a:r>
+              <a:rPr lang="en-IN" sz="1400" dirty="0">
+                <a:solidFill>
+                  <a:srgbClr val="5A5A5A"/>
+                </a:solidFill>
+                <a:latin typeface="Arial" pitchFamily="34" charset="0"/>
+                <a:ea typeface="Arial" pitchFamily="34" charset="-122"/>
+                <a:cs typeface="Arial" pitchFamily="34" charset="-120"/>
+              </a:rPr>
+              <a:t>Sovereign </a:t>
             </a:r>
             <a:endParaRPr lang="en-US" sz="1400" dirty="0"/>
           </a:p>
@@ -1912,7 +1768,7 @@
           <a:bodyPr wrap="square" lIns="0" tIns="0" rIns="0" bIns="0" rtlCol="0" anchor="ctr"/>
           <a:lstStyle/>
           <a:p>
-            <a:pPr indent="0" marL="0">
+            <a:pPr marL="0" indent="0">
               <a:buNone/>
             </a:pPr>
             <a:r>
@@ -1926,9 +1782,6 @@
               </a:rPr>
               <a:t>PROBLEM STATEMENT:  </a:t>
             </a:r>
-            <a:pPr indent="0" marL="0">
-              <a:buNone/>
-            </a:pPr>
             <a:r>
               <a:rPr lang="en-US" sz="1400" dirty="0">
                 <a:solidFill>
@@ -1965,7 +1818,7 @@
           <a:bodyPr wrap="square" lIns="0" tIns="0" rIns="0" bIns="0" rtlCol="0" anchor="ctr"/>
           <a:lstStyle/>
           <a:p>
-            <a:pPr indent="0" marL="0">
+            <a:pPr marL="0" indent="0">
               <a:buNone/>
             </a:pPr>
             <a:r>
@@ -1979,9 +1832,6 @@
               </a:rPr>
               <a:t>TEAM MEMBERS:  </a:t>
             </a:r>
-            <a:pPr indent="0" marL="0">
-              <a:buNone/>
-            </a:pPr>
             <a:r>
               <a:rPr lang="en-US" sz="1400" dirty="0">
                 <a:solidFill>
@@ -1991,7 +1841,29 @@
                 <a:ea typeface="Arial" pitchFamily="34" charset="-122"/>
                 <a:cs typeface="Arial" pitchFamily="34" charset="-120"/>
               </a:rPr>
-              <a:t>[Add team member names]</a:t>
+              <a:t>Aman Singh, Anusha Singh, Abhay Rawat, Aaditya, </a:t>
+            </a:r>
+            <a:r>
+              <a:rPr lang="en-US" sz="1400" dirty="0" err="1">
+                <a:solidFill>
+                  <a:srgbClr val="5A5A5A"/>
+                </a:solidFill>
+                <a:latin typeface="Arial" pitchFamily="34" charset="0"/>
+                <a:ea typeface="Arial" pitchFamily="34" charset="-122"/>
+                <a:cs typeface="Arial" pitchFamily="34" charset="-120"/>
+              </a:rPr>
+              <a:t>Tejshwini</a:t>
+            </a:r>
+            <a:r>
+              <a:rPr lang="en-US" sz="1400" dirty="0">
+                <a:solidFill>
+                  <a:srgbClr val="5A5A5A"/>
+                </a:solidFill>
+                <a:latin typeface="Arial" pitchFamily="34" charset="0"/>
+                <a:ea typeface="Arial" pitchFamily="34" charset="-122"/>
+                <a:cs typeface="Arial" pitchFamily="34" charset="-120"/>
+              </a:rPr>
+              <a:t> Rathore</a:t>
             </a:r>
             <a:endParaRPr lang="en-US" sz="1400" dirty="0"/>
           </a:p>
@@ -2018,7 +1890,7 @@
           <a:bodyPr wrap="square" lIns="0" tIns="0" rIns="0" bIns="0" rtlCol="0" anchor="ctr"/>
           <a:lstStyle/>
           <a:p>
-            <a:pPr indent="0" marL="0">
+            <a:pPr marL="0" indent="0">
               <a:buNone/>
             </a:pPr>
             <a:r>
@@ -2030,21 +1902,29 @@
                 <a:ea typeface="Arial" pitchFamily="34" charset="-122"/>
                 <a:cs typeface="Arial" pitchFamily="34" charset="-120"/>
               </a:rPr>
-              <a:t>COLLEGE:  </a:t>
-            </a:r>
-            <a:pPr indent="0" marL="0">
-              <a:buNone/>
-            </a:pPr>
+              <a:t>COLLEGE: </a:t>
+            </a:r>
             <a:r>
               <a:rPr lang="en-US" sz="1400" dirty="0">
                 <a:solidFill>
-                  <a:srgbClr val="5A5A5A"/>
-                </a:solidFill>
-                <a:latin typeface="Arial" pitchFamily="34" charset="0"/>
-                <a:ea typeface="Arial" pitchFamily="34" charset="-122"/>
-                <a:cs typeface="Arial" pitchFamily="34" charset="-120"/>
-              </a:rPr>
-              <a:t>National Institute of Technology, Delhi</a:t>
+                  <a:srgbClr val="1A1A1A"/>
+                </a:solidFill>
+                <a:latin typeface="Arial" pitchFamily="34" charset="0"/>
+                <a:ea typeface="Arial" pitchFamily="34" charset="-122"/>
+                <a:cs typeface="Arial" pitchFamily="34" charset="-120"/>
+              </a:rPr>
+              <a:t>Noida </a:t>
+            </a:r>
+            <a:r>
+              <a:rPr lang="en-IN" sz="1400" dirty="0">
+                <a:solidFill>
+                  <a:srgbClr val="1A1A1A"/>
+                </a:solidFill>
+                <a:latin typeface="Arial" pitchFamily="34" charset="0"/>
+                <a:ea typeface="Arial" pitchFamily="34" charset="-122"/>
+                <a:cs typeface="Arial" pitchFamily="34" charset="-120"/>
+              </a:rPr>
+              <a:t>Institute of Engineering &amp; Technology, Gr. Noida</a:t>
             </a:r>
             <a:endParaRPr lang="en-US" sz="1400" dirty="0"/>
           </a:p>
@@ -2066,6 +1946,7 @@
         <a:solidFill>
           <a:srgbClr val="FFFFFF"/>
         </a:solidFill>
+        <a:effectLst/>
       </p:bgPr>
     </p:bg>
     <p:spTree>
@@ -2084,55 +1965,7 @@
       </p:grpSpPr>
       <p:pic>
         <p:nvPicPr>
-          <p:cNvPr id="2" name="Image 0" descr="/home/claude/work/assets/watermark.png">    </p:cNvPr>
-          <p:cNvPicPr>
-            <a:picLocks noChangeAspect="1"/>
-          </p:cNvPicPr>
-          <p:nvPr/>
-        </p:nvPicPr>
-        <p:blipFill>
-          <a:blip r:embed="rId1"/>
-          <a:stretch>
-            <a:fillRect/>
-          </a:stretch>
-        </p:blipFill>
-        <p:spPr>
-          <a:xfrm>
-            <a:off x="3566160" y="914400"/>
-            <a:ext cx="5029200" cy="5029200"/>
-          </a:xfrm>
-          <a:prstGeom prst="rect">
-            <a:avLst/>
-          </a:prstGeom>
-        </p:spPr>
-      </p:pic>
-      <p:pic>
-        <p:nvPicPr>
-          <p:cNvPr id="3" name="Image 1" descr="/home/claude/work/assets/logo_nit.jpeg">    </p:cNvPr>
-          <p:cNvPicPr>
-            <a:picLocks noChangeAspect="1"/>
-          </p:cNvPicPr>
-          <p:nvPr/>
-        </p:nvPicPr>
-        <p:blipFill>
-          <a:blip r:embed="rId2"/>
-          <a:stretch>
-            <a:fillRect/>
-          </a:stretch>
-        </p:blipFill>
-        <p:spPr>
-          <a:xfrm>
-            <a:off x="457200" y="256032"/>
-            <a:ext cx="822960" cy="822960"/>
-          </a:xfrm>
-          <a:prstGeom prst="rect">
-            <a:avLst/>
-          </a:prstGeom>
-        </p:spPr>
-      </p:pic>
-      <p:pic>
-        <p:nvPicPr>
-          <p:cNvPr id="4" name="Image 2" descr="/home/claude/work/assets/logo_codeverse.jpeg">    </p:cNvPr>
+          <p:cNvPr id="2" name="Image 0" descr="/home/claude/work/assets/watermark.png"/>
           <p:cNvPicPr>
             <a:picLocks noChangeAspect="1"/>
           </p:cNvPicPr>
@@ -2146,8 +1979,8 @@
         </p:blipFill>
         <p:spPr>
           <a:xfrm>
-            <a:off x="5367528" y="109728"/>
-            <a:ext cx="1463040" cy="1188720"/>
+            <a:off x="3566160" y="914400"/>
+            <a:ext cx="5029200" cy="5029200"/>
           </a:xfrm>
           <a:prstGeom prst="rect">
             <a:avLst/>
@@ -2156,7 +1989,7 @@
       </p:pic>
       <p:pic>
         <p:nvPicPr>
-          <p:cNvPr id="5" name="Image 3" descr="/home/claude/work/assets/logo_up.jpeg">    </p:cNvPr>
+          <p:cNvPr id="3" name="Image 1" descr="/home/claude/work/assets/logo_nit.jpeg"/>
           <p:cNvPicPr>
             <a:picLocks noChangeAspect="1"/>
           </p:cNvPicPr>
@@ -2170,6 +2003,54 @@
         </p:blipFill>
         <p:spPr>
           <a:xfrm>
+            <a:off x="457200" y="256032"/>
+            <a:ext cx="822960" cy="822960"/>
+          </a:xfrm>
+          <a:prstGeom prst="rect">
+            <a:avLst/>
+          </a:prstGeom>
+        </p:spPr>
+      </p:pic>
+      <p:pic>
+        <p:nvPicPr>
+          <p:cNvPr id="4" name="Image 2" descr="/home/claude/work/assets/logo_codeverse.jpeg"/>
+          <p:cNvPicPr>
+            <a:picLocks noChangeAspect="1"/>
+          </p:cNvPicPr>
+          <p:nvPr/>
+        </p:nvPicPr>
+        <p:blipFill>
+          <a:blip r:embed="rId5"/>
+          <a:stretch>
+            <a:fillRect/>
+          </a:stretch>
+        </p:blipFill>
+        <p:spPr>
+          <a:xfrm>
+            <a:off x="5367528" y="109728"/>
+            <a:ext cx="1463040" cy="1188720"/>
+          </a:xfrm>
+          <a:prstGeom prst="rect">
+            <a:avLst/>
+          </a:prstGeom>
+        </p:spPr>
+      </p:pic>
+      <p:pic>
+        <p:nvPicPr>
+          <p:cNvPr id="5" name="Image 3" descr="/home/claude/work/assets/logo_up.jpeg"/>
+          <p:cNvPicPr>
+            <a:picLocks noChangeAspect="1"/>
+          </p:cNvPicPr>
+          <p:nvPr/>
+        </p:nvPicPr>
+        <p:blipFill>
+          <a:blip r:embed="rId6"/>
+          <a:stretch>
+            <a:fillRect/>
+          </a:stretch>
+        </p:blipFill>
+        <p:spPr>
+          <a:xfrm>
             <a:off x="10927080" y="292608"/>
             <a:ext cx="777240" cy="777240"/>
           </a:xfrm>
@@ -2239,7 +2120,7 @@
           <a:bodyPr wrap="square" lIns="0" tIns="0" rIns="0" bIns="0" rtlCol="0" anchor="ctr"/>
           <a:lstStyle/>
           <a:p>
-            <a:pPr algn="ctr" indent="0" marL="0">
+            <a:pPr marL="0" indent="0" algn="ctr">
               <a:buNone/>
             </a:pPr>
             <a:r>
@@ -2253,9 +2134,6 @@
               </a:rPr>
               <a:t>BUILD WITH  </a:t>
             </a:r>
-            <a:pPr algn="ctr" indent="0" marL="0">
-              <a:buNone/>
-            </a:pPr>
             <a:r>
               <a:rPr lang="en-US" sz="1000" b="1" dirty="0">
                 <a:solidFill>
@@ -2312,7 +2190,7 @@
           <a:bodyPr wrap="square" lIns="0" tIns="0" rIns="0" bIns="0" rtlCol="0" anchor="ctr"/>
           <a:lstStyle/>
           <a:p>
-            <a:pPr indent="0" marL="0">
+            <a:pPr marL="0" indent="0">
               <a:buNone/>
             </a:pPr>
             <a:r>
@@ -2394,7 +2272,7 @@
           <a:bodyPr wrap="square" lIns="0" tIns="0" rIns="0" bIns="0" rtlCol="0" anchor="ctr"/>
           <a:lstStyle/>
           <a:p>
-            <a:pPr indent="0" marL="0">
+            <a:pPr marL="0" indent="0">
               <a:buNone/>
             </a:pPr>
             <a:r>
@@ -2546,6 +2424,7 @@
         <a:solidFill>
           <a:srgbClr val="FFFFFF"/>
         </a:solidFill>
+        <a:effectLst/>
       </p:bgPr>
     </p:bg>
     <p:spTree>
@@ -2564,55 +2443,7 @@
       </p:grpSpPr>
       <p:pic>
         <p:nvPicPr>
-          <p:cNvPr id="2" name="Image 0" descr="/home/claude/work/assets/watermark.png">    </p:cNvPr>
-          <p:cNvPicPr>
-            <a:picLocks noChangeAspect="1"/>
-          </p:cNvPicPr>
-          <p:nvPr/>
-        </p:nvPicPr>
-        <p:blipFill>
-          <a:blip r:embed="rId1"/>
-          <a:stretch>
-            <a:fillRect/>
-          </a:stretch>
-        </p:blipFill>
-        <p:spPr>
-          <a:xfrm>
-            <a:off x="3566160" y="914400"/>
-            <a:ext cx="5029200" cy="5029200"/>
-          </a:xfrm>
-          <a:prstGeom prst="rect">
-            <a:avLst/>
-          </a:prstGeom>
-        </p:spPr>
-      </p:pic>
-      <p:pic>
-        <p:nvPicPr>
-          <p:cNvPr id="3" name="Image 1" descr="/home/claude/work/assets/logo_nit.jpeg">    </p:cNvPr>
-          <p:cNvPicPr>
-            <a:picLocks noChangeAspect="1"/>
-          </p:cNvPicPr>
-          <p:nvPr/>
-        </p:nvPicPr>
-        <p:blipFill>
-          <a:blip r:embed="rId2"/>
-          <a:stretch>
-            <a:fillRect/>
-          </a:stretch>
-        </p:blipFill>
-        <p:spPr>
-          <a:xfrm>
-            <a:off x="457200" y="256032"/>
-            <a:ext cx="822960" cy="822960"/>
-          </a:xfrm>
-          <a:prstGeom prst="rect">
-            <a:avLst/>
-          </a:prstGeom>
-        </p:spPr>
-      </p:pic>
-      <p:pic>
-        <p:nvPicPr>
-          <p:cNvPr id="4" name="Image 2" descr="/home/claude/work/assets/logo_codeverse.jpeg">    </p:cNvPr>
+          <p:cNvPr id="2" name="Image 0" descr="/home/claude/work/assets/watermark.png"/>
           <p:cNvPicPr>
             <a:picLocks noChangeAspect="1"/>
           </p:cNvPicPr>
@@ -2626,8 +2457,8 @@
         </p:blipFill>
         <p:spPr>
           <a:xfrm>
-            <a:off x="5367528" y="109728"/>
-            <a:ext cx="1463040" cy="1188720"/>
+            <a:off x="3566160" y="914400"/>
+            <a:ext cx="5029200" cy="5029200"/>
           </a:xfrm>
           <a:prstGeom prst="rect">
             <a:avLst/>
@@ -2636,7 +2467,7 @@
       </p:pic>
       <p:pic>
         <p:nvPicPr>
-          <p:cNvPr id="5" name="Image 3" descr="/home/claude/work/assets/logo_up.jpeg">    </p:cNvPr>
+          <p:cNvPr id="3" name="Image 1" descr="/home/claude/work/assets/logo_nit.jpeg"/>
           <p:cNvPicPr>
             <a:picLocks noChangeAspect="1"/>
           </p:cNvPicPr>
@@ -2650,6 +2481,54 @@
         </p:blipFill>
         <p:spPr>
           <a:xfrm>
+            <a:off x="457200" y="256032"/>
+            <a:ext cx="822960" cy="822960"/>
+          </a:xfrm>
+          <a:prstGeom prst="rect">
+            <a:avLst/>
+          </a:prstGeom>
+        </p:spPr>
+      </p:pic>
+      <p:pic>
+        <p:nvPicPr>
+          <p:cNvPr id="4" name="Image 2" descr="/home/claude/work/assets/logo_codeverse.jpeg"/>
+          <p:cNvPicPr>
+            <a:picLocks noChangeAspect="1"/>
+          </p:cNvPicPr>
+          <p:nvPr/>
+        </p:nvPicPr>
+        <p:blipFill>
+          <a:blip r:embed="rId5"/>
+          <a:stretch>
+            <a:fillRect/>
+          </a:stretch>
+        </p:blipFill>
+        <p:spPr>
+          <a:xfrm>
+            <a:off x="5367528" y="109728"/>
+            <a:ext cx="1463040" cy="1188720"/>
+          </a:xfrm>
+          <a:prstGeom prst="rect">
+            <a:avLst/>
+          </a:prstGeom>
+        </p:spPr>
+      </p:pic>
+      <p:pic>
+        <p:nvPicPr>
+          <p:cNvPr id="5" name="Image 3" descr="/home/claude/work/assets/logo_up.jpeg"/>
+          <p:cNvPicPr>
+            <a:picLocks noChangeAspect="1"/>
+          </p:cNvPicPr>
+          <p:nvPr/>
+        </p:nvPicPr>
+        <p:blipFill>
+          <a:blip r:embed="rId6"/>
+          <a:stretch>
+            <a:fillRect/>
+          </a:stretch>
+        </p:blipFill>
+        <p:spPr>
+          <a:xfrm>
             <a:off x="10927080" y="292608"/>
             <a:ext cx="777240" cy="777240"/>
           </a:xfrm>
@@ -2719,7 +2598,7 @@
           <a:bodyPr wrap="square" lIns="0" tIns="0" rIns="0" bIns="0" rtlCol="0" anchor="ctr"/>
           <a:lstStyle/>
           <a:p>
-            <a:pPr algn="ctr" indent="0" marL="0">
+            <a:pPr marL="0" indent="0" algn="ctr">
               <a:buNone/>
             </a:pPr>
             <a:r>
@@ -2733,9 +2612,6 @@
               </a:rPr>
               <a:t>BUILD WITH  </a:t>
             </a:r>
-            <a:pPr algn="ctr" indent="0" marL="0">
-              <a:buNone/>
-            </a:pPr>
             <a:r>
               <a:rPr lang="en-US" sz="1000" b="1" dirty="0">
                 <a:solidFill>
@@ -2792,7 +2668,7 @@
           <a:bodyPr wrap="square" lIns="0" tIns="0" rIns="0" bIns="0" rtlCol="0" anchor="ctr"/>
           <a:lstStyle/>
           <a:p>
-            <a:pPr indent="0" marL="0">
+            <a:pPr marL="0" indent="0">
               <a:buNone/>
             </a:pPr>
             <a:r>
@@ -2874,7 +2750,7 @@
           <a:bodyPr wrap="square" lIns="0" tIns="0" rIns="0" bIns="0" rtlCol="0" anchor="ctr"/>
           <a:lstStyle/>
           <a:p>
-            <a:pPr indent="0" marL="0">
+            <a:pPr marL="0" indent="0">
               <a:buNone/>
             </a:pPr>
             <a:r>
@@ -2913,7 +2789,7 @@
           <a:bodyPr wrap="square" lIns="0" tIns="0" rIns="0" bIns="0" rtlCol="0" anchor="ctr"/>
           <a:lstStyle/>
           <a:p>
-            <a:pPr indent="0" marL="0">
+            <a:pPr marL="0" indent="0">
               <a:buNone/>
             </a:pPr>
             <a:r>
@@ -2974,7 +2850,7 @@
           <a:bodyPr wrap="square" lIns="0" tIns="0" rIns="0" bIns="0" rtlCol="0" anchor="ctr"/>
           <a:lstStyle/>
           <a:p>
-            <a:pPr indent="0" marL="0">
+            <a:pPr marL="0" indent="0">
               <a:buNone/>
             </a:pPr>
             <a:r>
@@ -3013,7 +2889,7 @@
           <a:bodyPr wrap="square" lIns="0" tIns="0" rIns="0" bIns="0" rtlCol="0" anchor="t"/>
           <a:lstStyle/>
           <a:p>
-            <a:pPr indent="0" marL="0">
+            <a:pPr marL="0" indent="0">
               <a:buNone/>
             </a:pPr>
             <a:r>
@@ -3074,7 +2950,7 @@
           <a:bodyPr wrap="square" lIns="0" tIns="0" rIns="0" bIns="0" rtlCol="0" anchor="ctr"/>
           <a:lstStyle/>
           <a:p>
-            <a:pPr indent="0" marL="0">
+            <a:pPr marL="0" indent="0">
               <a:buNone/>
             </a:pPr>
             <a:r>
@@ -3113,7 +2989,7 @@
           <a:bodyPr wrap="square" lIns="0" tIns="0" rIns="0" bIns="0" rtlCol="0" anchor="t"/>
           <a:lstStyle/>
           <a:p>
-            <a:pPr indent="0" marL="0">
+            <a:pPr marL="0" indent="0">
               <a:buNone/>
             </a:pPr>
             <a:r>
@@ -3152,7 +3028,7 @@
           <a:bodyPr wrap="square" lIns="0" tIns="0" rIns="0" bIns="0" rtlCol="0" anchor="ctr"/>
           <a:lstStyle/>
           <a:p>
-            <a:pPr indent="0" marL="0">
+            <a:pPr marL="0" indent="0">
               <a:buNone/>
             </a:pPr>
             <a:r>
@@ -3280,6 +3156,7 @@
         <a:solidFill>
           <a:srgbClr val="FFFFFF"/>
         </a:solidFill>
+        <a:effectLst/>
       </p:bgPr>
     </p:bg>
     <p:spTree>
@@ -3298,55 +3175,7 @@
       </p:grpSpPr>
       <p:pic>
         <p:nvPicPr>
-          <p:cNvPr id="2" name="Image 0" descr="/home/claude/work/assets/logo_nit.jpeg">    </p:cNvPr>
-          <p:cNvPicPr>
-            <a:picLocks noChangeAspect="1"/>
-          </p:cNvPicPr>
-          <p:nvPr/>
-        </p:nvPicPr>
-        <p:blipFill>
-          <a:blip r:embed="rId1"/>
-          <a:stretch>
-            <a:fillRect/>
-          </a:stretch>
-        </p:blipFill>
-        <p:spPr>
-          <a:xfrm>
-            <a:off x="457200" y="256032"/>
-            <a:ext cx="822960" cy="822960"/>
-          </a:xfrm>
-          <a:prstGeom prst="rect">
-            <a:avLst/>
-          </a:prstGeom>
-        </p:spPr>
-      </p:pic>
-      <p:pic>
-        <p:nvPicPr>
-          <p:cNvPr id="3" name="Image 1" descr="/home/claude/work/assets/logo_codeverse.jpeg">    </p:cNvPr>
-          <p:cNvPicPr>
-            <a:picLocks noChangeAspect="1"/>
-          </p:cNvPicPr>
-          <p:nvPr/>
-        </p:nvPicPr>
-        <p:blipFill>
-          <a:blip r:embed="rId2"/>
-          <a:stretch>
-            <a:fillRect/>
-          </a:stretch>
-        </p:blipFill>
-        <p:spPr>
-          <a:xfrm>
-            <a:off x="5367528" y="109728"/>
-            <a:ext cx="1463040" cy="1188720"/>
-          </a:xfrm>
-          <a:prstGeom prst="rect">
-            <a:avLst/>
-          </a:prstGeom>
-        </p:spPr>
-      </p:pic>
-      <p:pic>
-        <p:nvPicPr>
-          <p:cNvPr id="4" name="Image 2" descr="/home/claude/work/assets/logo_up.jpeg">    </p:cNvPr>
+          <p:cNvPr id="2" name="Image 0" descr="/home/claude/work/assets/logo_nit.jpeg"/>
           <p:cNvPicPr>
             <a:picLocks noChangeAspect="1"/>
           </p:cNvPicPr>
@@ -3360,6 +3189,54 @@
         </p:blipFill>
         <p:spPr>
           <a:xfrm>
+            <a:off x="457200" y="256032"/>
+            <a:ext cx="822960" cy="822960"/>
+          </a:xfrm>
+          <a:prstGeom prst="rect">
+            <a:avLst/>
+          </a:prstGeom>
+        </p:spPr>
+      </p:pic>
+      <p:pic>
+        <p:nvPicPr>
+          <p:cNvPr id="3" name="Image 1" descr="/home/claude/work/assets/logo_codeverse.jpeg"/>
+          <p:cNvPicPr>
+            <a:picLocks noChangeAspect="1"/>
+          </p:cNvPicPr>
+          <p:nvPr/>
+        </p:nvPicPr>
+        <p:blipFill>
+          <a:blip r:embed="rId4"/>
+          <a:stretch>
+            <a:fillRect/>
+          </a:stretch>
+        </p:blipFill>
+        <p:spPr>
+          <a:xfrm>
+            <a:off x="5367528" y="109728"/>
+            <a:ext cx="1463040" cy="1188720"/>
+          </a:xfrm>
+          <a:prstGeom prst="rect">
+            <a:avLst/>
+          </a:prstGeom>
+        </p:spPr>
+      </p:pic>
+      <p:pic>
+        <p:nvPicPr>
+          <p:cNvPr id="4" name="Image 2" descr="/home/claude/work/assets/logo_up.jpeg"/>
+          <p:cNvPicPr>
+            <a:picLocks noChangeAspect="1"/>
+          </p:cNvPicPr>
+          <p:nvPr/>
+        </p:nvPicPr>
+        <p:blipFill>
+          <a:blip r:embed="rId5"/>
+          <a:stretch>
+            <a:fillRect/>
+          </a:stretch>
+        </p:blipFill>
+        <p:spPr>
+          <a:xfrm>
             <a:off x="10927080" y="292608"/>
             <a:ext cx="777240" cy="777240"/>
           </a:xfrm>
@@ -3429,7 +3306,7 @@
           <a:bodyPr wrap="square" lIns="0" tIns="0" rIns="0" bIns="0" rtlCol="0" anchor="ctr"/>
           <a:lstStyle/>
           <a:p>
-            <a:pPr algn="ctr" indent="0" marL="0">
+            <a:pPr marL="0" indent="0" algn="ctr">
               <a:buNone/>
             </a:pPr>
             <a:r>
@@ -3443,9 +3320,6 @@
               </a:rPr>
               <a:t>BUILD WITH  </a:t>
             </a:r>
-            <a:pPr algn="ctr" indent="0" marL="0">
-              <a:buNone/>
-            </a:pPr>
             <a:r>
               <a:rPr lang="en-US" sz="1000" b="1" dirty="0">
                 <a:solidFill>
@@ -3502,7 +3376,7 @@
           <a:bodyPr wrap="square" lIns="0" tIns="0" rIns="0" bIns="0" rtlCol="0" anchor="ctr"/>
           <a:lstStyle/>
           <a:p>
-            <a:pPr indent="0" marL="0">
+            <a:pPr marL="0" indent="0">
               <a:buNone/>
             </a:pPr>
             <a:r>
@@ -3606,7 +3480,7 @@
           <a:bodyPr wrap="square" lIns="0" tIns="0" rIns="0" bIns="0" rtlCol="0" anchor="ctr"/>
           <a:lstStyle/>
           <a:p>
-            <a:pPr algn="ctr" indent="0" marL="0">
+            <a:pPr marL="0" indent="0" algn="ctr">
               <a:buNone/>
             </a:pPr>
             <a:r>
@@ -3687,7 +3561,7 @@
           <a:bodyPr wrap="square" lIns="0" tIns="0" rIns="0" bIns="0" rtlCol="0" anchor="ctr"/>
           <a:lstStyle/>
           <a:p>
-            <a:pPr algn="ctr" indent="0" marL="0">
+            <a:pPr marL="0" indent="0" algn="ctr">
               <a:buNone/>
             </a:pPr>
             <a:r>
@@ -3704,7 +3578,7 @@
             <a:endParaRPr lang="en-US" sz="1050" dirty="0"/>
           </a:p>
           <a:p>
-            <a:pPr algn="ctr" indent="0" marL="0">
+            <a:pPr marL="0" indent="0" algn="ctr">
               <a:buNone/>
             </a:pPr>
             <a:r>
@@ -3785,7 +3659,7 @@
           <a:bodyPr wrap="square" lIns="0" tIns="0" rIns="0" bIns="0" rtlCol="0" anchor="ctr"/>
           <a:lstStyle/>
           <a:p>
-            <a:pPr algn="ctr" indent="0" marL="0">
+            <a:pPr marL="0" indent="0" algn="ctr">
               <a:buNone/>
             </a:pPr>
             <a:r>
@@ -3802,7 +3676,7 @@
             <a:endParaRPr lang="en-US" sz="1050" dirty="0"/>
           </a:p>
           <a:p>
-            <a:pPr algn="ctr" indent="0" marL="0">
+            <a:pPr marL="0" indent="0" algn="ctr">
               <a:buNone/>
             </a:pPr>
             <a:r>
@@ -3863,7 +3737,7 @@
           <a:bodyPr wrap="square" lIns="0" tIns="0" rIns="0" bIns="0" rtlCol="0" anchor="ctr"/>
           <a:lstStyle/>
           <a:p>
-            <a:pPr algn="ctr" indent="0" marL="0">
+            <a:pPr marL="0" indent="0" algn="ctr">
               <a:buNone/>
             </a:pPr>
             <a:r>
@@ -3944,7 +3818,7 @@
           <a:bodyPr wrap="square" lIns="0" tIns="0" rIns="0" bIns="0" rtlCol="0" anchor="ctr"/>
           <a:lstStyle/>
           <a:p>
-            <a:pPr algn="ctr" indent="0" marL="0">
+            <a:pPr marL="0" indent="0" algn="ctr">
               <a:buNone/>
             </a:pPr>
             <a:r>
@@ -3961,7 +3835,7 @@
             <a:endParaRPr lang="en-US" sz="1050" dirty="0"/>
           </a:p>
           <a:p>
-            <a:pPr algn="ctr" indent="0" marL="0">
+            <a:pPr marL="0" indent="0" algn="ctr">
               <a:buNone/>
             </a:pPr>
             <a:r>
@@ -4042,7 +3916,7 @@
           <a:bodyPr wrap="square" lIns="0" tIns="0" rIns="0" bIns="0" rtlCol="0" anchor="ctr"/>
           <a:lstStyle/>
           <a:p>
-            <a:pPr algn="ctr" indent="0" marL="0">
+            <a:pPr marL="0" indent="0" algn="ctr">
               <a:buNone/>
             </a:pPr>
             <a:r>
@@ -4059,7 +3933,7 @@
             <a:endParaRPr lang="en-US" sz="1050" dirty="0"/>
           </a:p>
           <a:p>
-            <a:pPr algn="ctr" indent="0" marL="0">
+            <a:pPr marL="0" indent="0" algn="ctr">
               <a:buNone/>
             </a:pPr>
             <a:r>
@@ -4140,7 +4014,7 @@
           <a:bodyPr wrap="square" lIns="0" tIns="0" rIns="0" bIns="0" rtlCol="0" anchor="ctr"/>
           <a:lstStyle/>
           <a:p>
-            <a:pPr algn="ctr" indent="0" marL="0">
+            <a:pPr marL="0" indent="0" algn="ctr">
               <a:buNone/>
             </a:pPr>
             <a:r>
@@ -4221,7 +4095,7 @@
           <a:bodyPr wrap="square" lIns="0" tIns="0" rIns="0" bIns="0" rtlCol="0" anchor="ctr"/>
           <a:lstStyle/>
           <a:p>
-            <a:pPr algn="ctr" indent="0" marL="0">
+            <a:pPr marL="0" indent="0" algn="ctr">
               <a:buNone/>
             </a:pPr>
             <a:r>
@@ -4302,7 +4176,7 @@
           <a:bodyPr wrap="square" lIns="0" tIns="0" rIns="0" bIns="0" rtlCol="0" anchor="ctr"/>
           <a:lstStyle/>
           <a:p>
-            <a:pPr algn="ctr" indent="0" marL="0">
+            <a:pPr marL="0" indent="0" algn="ctr">
               <a:buNone/>
             </a:pPr>
             <a:r>
@@ -4363,7 +4237,7 @@
           <a:bodyPr wrap="square" lIns="0" tIns="0" rIns="0" bIns="0" rtlCol="0" anchor="ctr"/>
           <a:lstStyle/>
           <a:p>
-            <a:pPr algn="ctr" indent="0" marL="0">
+            <a:pPr marL="0" indent="0" algn="ctr">
               <a:buNone/>
             </a:pPr>
             <a:r>
@@ -4380,7 +4254,7 @@
             <a:endParaRPr lang="en-US" sz="1100" dirty="0"/>
           </a:p>
           <a:p>
-            <a:pPr algn="ctr" indent="0" marL="0">
+            <a:pPr marL="0" indent="0" algn="ctr">
               <a:buNone/>
             </a:pPr>
             <a:r>
@@ -4407,7 +4281,7 @@
         <p:spPr>
           <a:xfrm>
             <a:off x="548640" y="5843016"/>
-            <a:ext cx="11064240" cy="365760"/>
+            <a:ext cx="11311128" cy="365760"/>
           </a:xfrm>
           <a:prstGeom prst="rect">
             <a:avLst/>
@@ -4419,19 +4293,18 @@
           <a:bodyPr wrap="square" lIns="0" tIns="0" rIns="0" bIns="0" rtlCol="0" anchor="ctr"/>
           <a:lstStyle/>
           <a:p>
-            <a:pPr algn="ctr" indent="0" marL="0">
-              <a:buNone/>
-            </a:pPr>
-            <a:r>
-              <a:rPr lang="en-US" sz="1100" i="1" dirty="0">
-                <a:solidFill>
-                  <a:srgbClr val="5A5A5A"/>
-                </a:solidFill>
-                <a:latin typeface="Arial" pitchFamily="34" charset="0"/>
-                <a:ea typeface="Arial" pitchFamily="34" charset="-122"/>
-                <a:cs typeface="Arial" pitchFamily="34" charset="-120"/>
-              </a:rPr>
-              <a:t>Engineering risk: camera frames and audio buffers run on different latencies — both streams must be timestamp-fused, or the on-screen chord/strum output will visibly drift.</a:t>
+            <a:pPr algn="ctr"/>
+            <a:r>
+              <a:rPr lang="en-IN" sz="1100" dirty="0"/>
+              <a:t>Engineering risk: camera frames and audio buffers run on different latencies — </a:t>
+            </a:r>
+            <a:r>
+              <a:rPr lang="en-IN" sz="1100" dirty="0" err="1"/>
+              <a:t>StrumSense</a:t>
+            </a:r>
+            <a:r>
+              <a:rPr lang="en-IN" sz="1100" dirty="0"/>
+              <a:t> uses timestamp-based fusion to keep chord detection and strumming feedback synchronized, preventing visible drift.</a:t>
             </a:r>
             <a:endParaRPr lang="en-US" sz="1100" dirty="0"/>
           </a:p>
@@ -4453,6 +4326,7 @@
         <a:solidFill>
           <a:srgbClr val="FFFFFF"/>
         </a:solidFill>
+        <a:effectLst/>
       </p:bgPr>
     </p:bg>
     <p:spTree>
@@ -4471,55 +4345,7 @@
       </p:grpSpPr>
       <p:pic>
         <p:nvPicPr>
-          <p:cNvPr id="2" name="Image 0" descr="/home/claude/work/assets/logo_nit.jpeg">    </p:cNvPr>
-          <p:cNvPicPr>
-            <a:picLocks noChangeAspect="1"/>
-          </p:cNvPicPr>
-          <p:nvPr/>
-        </p:nvPicPr>
-        <p:blipFill>
-          <a:blip r:embed="rId1"/>
-          <a:stretch>
-            <a:fillRect/>
-          </a:stretch>
-        </p:blipFill>
-        <p:spPr>
-          <a:xfrm>
-            <a:off x="457200" y="256032"/>
-            <a:ext cx="822960" cy="822960"/>
-          </a:xfrm>
-          <a:prstGeom prst="rect">
-            <a:avLst/>
-          </a:prstGeom>
-        </p:spPr>
-      </p:pic>
-      <p:pic>
-        <p:nvPicPr>
-          <p:cNvPr id="3" name="Image 1" descr="/home/claude/work/assets/logo_codeverse.jpeg">    </p:cNvPr>
-          <p:cNvPicPr>
-            <a:picLocks noChangeAspect="1"/>
-          </p:cNvPicPr>
-          <p:nvPr/>
-        </p:nvPicPr>
-        <p:blipFill>
-          <a:blip r:embed="rId2"/>
-          <a:stretch>
-            <a:fillRect/>
-          </a:stretch>
-        </p:blipFill>
-        <p:spPr>
-          <a:xfrm>
-            <a:off x="5367528" y="109728"/>
-            <a:ext cx="1463040" cy="1188720"/>
-          </a:xfrm>
-          <a:prstGeom prst="rect">
-            <a:avLst/>
-          </a:prstGeom>
-        </p:spPr>
-      </p:pic>
-      <p:pic>
-        <p:nvPicPr>
-          <p:cNvPr id="4" name="Image 2" descr="/home/claude/work/assets/logo_up.jpeg">    </p:cNvPr>
+          <p:cNvPr id="2" name="Image 0" descr="/home/claude/work/assets/logo_nit.jpeg"/>
           <p:cNvPicPr>
             <a:picLocks noChangeAspect="1"/>
           </p:cNvPicPr>
@@ -4533,6 +4359,54 @@
         </p:blipFill>
         <p:spPr>
           <a:xfrm>
+            <a:off x="457200" y="256032"/>
+            <a:ext cx="822960" cy="822960"/>
+          </a:xfrm>
+          <a:prstGeom prst="rect">
+            <a:avLst/>
+          </a:prstGeom>
+        </p:spPr>
+      </p:pic>
+      <p:pic>
+        <p:nvPicPr>
+          <p:cNvPr id="3" name="Image 1" descr="/home/claude/work/assets/logo_codeverse.jpeg"/>
+          <p:cNvPicPr>
+            <a:picLocks noChangeAspect="1"/>
+          </p:cNvPicPr>
+          <p:nvPr/>
+        </p:nvPicPr>
+        <p:blipFill>
+          <a:blip r:embed="rId4"/>
+          <a:stretch>
+            <a:fillRect/>
+          </a:stretch>
+        </p:blipFill>
+        <p:spPr>
+          <a:xfrm>
+            <a:off x="5367528" y="109728"/>
+            <a:ext cx="1463040" cy="1188720"/>
+          </a:xfrm>
+          <a:prstGeom prst="rect">
+            <a:avLst/>
+          </a:prstGeom>
+        </p:spPr>
+      </p:pic>
+      <p:pic>
+        <p:nvPicPr>
+          <p:cNvPr id="4" name="Image 2" descr="/home/claude/work/assets/logo_up.jpeg"/>
+          <p:cNvPicPr>
+            <a:picLocks noChangeAspect="1"/>
+          </p:cNvPicPr>
+          <p:nvPr/>
+        </p:nvPicPr>
+        <p:blipFill>
+          <a:blip r:embed="rId5"/>
+          <a:stretch>
+            <a:fillRect/>
+          </a:stretch>
+        </p:blipFill>
+        <p:spPr>
+          <a:xfrm>
             <a:off x="10927080" y="292608"/>
             <a:ext cx="777240" cy="777240"/>
           </a:xfrm>
@@ -4602,7 +4476,7 @@
           <a:bodyPr wrap="square" lIns="0" tIns="0" rIns="0" bIns="0" rtlCol="0" anchor="ctr"/>
           <a:lstStyle/>
           <a:p>
-            <a:pPr algn="ctr" indent="0" marL="0">
+            <a:pPr marL="0" indent="0" algn="ctr">
               <a:buNone/>
             </a:pPr>
             <a:r>
@@ -4616,9 +4490,6 @@
               </a:rPr>
               <a:t>BUILD WITH  </a:t>
             </a:r>
-            <a:pPr algn="ctr" indent="0" marL="0">
-              <a:buNone/>
-            </a:pPr>
             <a:r>
               <a:rPr lang="en-US" sz="1000" b="1" dirty="0">
                 <a:solidFill>
@@ -4675,7 +4546,7 @@
           <a:bodyPr wrap="square" lIns="0" tIns="0" rIns="0" bIns="0" rtlCol="0" anchor="ctr"/>
           <a:lstStyle/>
           <a:p>
-            <a:pPr indent="0" marL="0">
+            <a:pPr marL="0" indent="0">
               <a:buNone/>
             </a:pPr>
             <a:r>
@@ -4777,7 +4648,7 @@
           <a:bodyPr wrap="square" lIns="0" tIns="0" rIns="0" bIns="0" rtlCol="0" anchor="t"/>
           <a:lstStyle/>
           <a:p>
-            <a:pPr indent="0" marL="0">
+            <a:pPr marL="0" indent="0">
               <a:buNone/>
             </a:pPr>
             <a:r>
@@ -4816,7 +4687,7 @@
           <a:bodyPr wrap="square" lIns="0" tIns="0" rIns="0" bIns="0" rtlCol="0" anchor="t"/>
           <a:lstStyle/>
           <a:p>
-            <a:pPr indent="0" marL="0">
+            <a:pPr marL="0" indent="0">
               <a:buNone/>
             </a:pPr>
             <a:r>
@@ -4875,7 +4746,7 @@
           <a:bodyPr wrap="square" lIns="0" tIns="0" rIns="0" bIns="0" rtlCol="0" anchor="t"/>
           <a:lstStyle/>
           <a:p>
-            <a:pPr indent="0" marL="0">
+            <a:pPr marL="0" indent="0">
               <a:buNone/>
             </a:pPr>
             <a:r>
@@ -4914,7 +4785,7 @@
           <a:bodyPr wrap="square" lIns="0" tIns="0" rIns="0" bIns="0" rtlCol="0" anchor="t"/>
           <a:lstStyle/>
           <a:p>
-            <a:pPr indent="0" marL="0">
+            <a:pPr marL="0" indent="0">
               <a:buNone/>
             </a:pPr>
             <a:r>
@@ -4973,7 +4844,7 @@
           <a:bodyPr wrap="square" lIns="0" tIns="0" rIns="0" bIns="0" rtlCol="0" anchor="t"/>
           <a:lstStyle/>
           <a:p>
-            <a:pPr indent="0" marL="0">
+            <a:pPr marL="0" indent="0">
               <a:buNone/>
             </a:pPr>
             <a:r>
@@ -5012,7 +4883,7 @@
           <a:bodyPr wrap="square" lIns="0" tIns="0" rIns="0" bIns="0" rtlCol="0" anchor="t"/>
           <a:lstStyle/>
           <a:p>
-            <a:pPr indent="0" marL="0">
+            <a:pPr marL="0" indent="0">
               <a:buNone/>
             </a:pPr>
             <a:r>
@@ -5071,7 +4942,7 @@
           <a:bodyPr wrap="square" lIns="0" tIns="0" rIns="0" bIns="0" rtlCol="0" anchor="t"/>
           <a:lstStyle/>
           <a:p>
-            <a:pPr indent="0" marL="0">
+            <a:pPr marL="0" indent="0">
               <a:buNone/>
             </a:pPr>
             <a:r>
@@ -5110,7 +4981,7 @@
           <a:bodyPr wrap="square" lIns="0" tIns="0" rIns="0" bIns="0" rtlCol="0" anchor="t"/>
           <a:lstStyle/>
           <a:p>
-            <a:pPr indent="0" marL="0">
+            <a:pPr marL="0" indent="0">
               <a:buNone/>
             </a:pPr>
             <a:r>
@@ -5144,6 +5015,7 @@
         <a:solidFill>
           <a:srgbClr val="FFFFFF"/>
         </a:solidFill>
+        <a:effectLst/>
       </p:bgPr>
     </p:bg>
     <p:spTree>
@@ -5162,55 +5034,7 @@
       </p:grpSpPr>
       <p:pic>
         <p:nvPicPr>
-          <p:cNvPr id="2" name="Image 0" descr="/home/claude/work/assets/logo_nit.jpeg">    </p:cNvPr>
-          <p:cNvPicPr>
-            <a:picLocks noChangeAspect="1"/>
-          </p:cNvPicPr>
-          <p:nvPr/>
-        </p:nvPicPr>
-        <p:blipFill>
-          <a:blip r:embed="rId1"/>
-          <a:stretch>
-            <a:fillRect/>
-          </a:stretch>
-        </p:blipFill>
-        <p:spPr>
-          <a:xfrm>
-            <a:off x="457200" y="256032"/>
-            <a:ext cx="822960" cy="822960"/>
-          </a:xfrm>
-          <a:prstGeom prst="rect">
-            <a:avLst/>
-          </a:prstGeom>
-        </p:spPr>
-      </p:pic>
-      <p:pic>
-        <p:nvPicPr>
-          <p:cNvPr id="3" name="Image 1" descr="/home/claude/work/assets/logo_codeverse.jpeg">    </p:cNvPr>
-          <p:cNvPicPr>
-            <a:picLocks noChangeAspect="1"/>
-          </p:cNvPicPr>
-          <p:nvPr/>
-        </p:nvPicPr>
-        <p:blipFill>
-          <a:blip r:embed="rId2"/>
-          <a:stretch>
-            <a:fillRect/>
-          </a:stretch>
-        </p:blipFill>
-        <p:spPr>
-          <a:xfrm>
-            <a:off x="5367528" y="109728"/>
-            <a:ext cx="1463040" cy="1188720"/>
-          </a:xfrm>
-          <a:prstGeom prst="rect">
-            <a:avLst/>
-          </a:prstGeom>
-        </p:spPr>
-      </p:pic>
-      <p:pic>
-        <p:nvPicPr>
-          <p:cNvPr id="4" name="Image 2" descr="/home/claude/work/assets/logo_up.jpeg">    </p:cNvPr>
+          <p:cNvPr id="2" name="Image 0" descr="/home/claude/work/assets/logo_nit.jpeg"/>
           <p:cNvPicPr>
             <a:picLocks noChangeAspect="1"/>
           </p:cNvPicPr>
@@ -5224,6 +5048,54 @@
         </p:blipFill>
         <p:spPr>
           <a:xfrm>
+            <a:off x="457200" y="256032"/>
+            <a:ext cx="822960" cy="822960"/>
+          </a:xfrm>
+          <a:prstGeom prst="rect">
+            <a:avLst/>
+          </a:prstGeom>
+        </p:spPr>
+      </p:pic>
+      <p:pic>
+        <p:nvPicPr>
+          <p:cNvPr id="3" name="Image 1" descr="/home/claude/work/assets/logo_codeverse.jpeg"/>
+          <p:cNvPicPr>
+            <a:picLocks noChangeAspect="1"/>
+          </p:cNvPicPr>
+          <p:nvPr/>
+        </p:nvPicPr>
+        <p:blipFill>
+          <a:blip r:embed="rId4"/>
+          <a:stretch>
+            <a:fillRect/>
+          </a:stretch>
+        </p:blipFill>
+        <p:spPr>
+          <a:xfrm>
+            <a:off x="5367528" y="109728"/>
+            <a:ext cx="1463040" cy="1188720"/>
+          </a:xfrm>
+          <a:prstGeom prst="rect">
+            <a:avLst/>
+          </a:prstGeom>
+        </p:spPr>
+      </p:pic>
+      <p:pic>
+        <p:nvPicPr>
+          <p:cNvPr id="4" name="Image 2" descr="/home/claude/work/assets/logo_up.jpeg"/>
+          <p:cNvPicPr>
+            <a:picLocks noChangeAspect="1"/>
+          </p:cNvPicPr>
+          <p:nvPr/>
+        </p:nvPicPr>
+        <p:blipFill>
+          <a:blip r:embed="rId5"/>
+          <a:stretch>
+            <a:fillRect/>
+          </a:stretch>
+        </p:blipFill>
+        <p:spPr>
+          <a:xfrm>
             <a:off x="10927080" y="292608"/>
             <a:ext cx="777240" cy="777240"/>
           </a:xfrm>
@@ -5293,7 +5165,7 @@
           <a:bodyPr wrap="square" lIns="0" tIns="0" rIns="0" bIns="0" rtlCol="0" anchor="ctr"/>
           <a:lstStyle/>
           <a:p>
-            <a:pPr algn="ctr" indent="0" marL="0">
+            <a:pPr marL="0" indent="0" algn="ctr">
               <a:buNone/>
             </a:pPr>
             <a:r>
@@ -5307,9 +5179,6 @@
               </a:rPr>
               <a:t>BUILD WITH  </a:t>
             </a:r>
-            <a:pPr algn="ctr" indent="0" marL="0">
-              <a:buNone/>
-            </a:pPr>
             <a:r>
               <a:rPr lang="en-US" sz="1000" b="1" dirty="0">
                 <a:solidFill>
@@ -5366,7 +5235,7 @@
           <a:bodyPr wrap="square" lIns="0" tIns="0" rIns="0" bIns="0" rtlCol="0" anchor="ctr"/>
           <a:lstStyle/>
           <a:p>
-            <a:pPr indent="0" marL="0">
+            <a:pPr marL="0" indent="0">
               <a:buNone/>
             </a:pPr>
             <a:r>
@@ -5490,7 +5359,7 @@
           <a:bodyPr wrap="square" lIns="0" tIns="0" rIns="0" bIns="0" rtlCol="0" anchor="ctr"/>
           <a:lstStyle/>
           <a:p>
-            <a:pPr indent="0" marL="0">
+            <a:pPr marL="0" indent="0">
               <a:buNone/>
             </a:pPr>
             <a:r>
@@ -5529,7 +5398,7 @@
           <a:bodyPr wrap="square" lIns="0" tIns="0" rIns="0" bIns="0" rtlCol="0" anchor="t"/>
           <a:lstStyle/>
           <a:p>
-            <a:pPr indent="0" marL="0">
+            <a:pPr marL="0" indent="0">
               <a:buNone/>
             </a:pPr>
             <a:r>
@@ -5610,7 +5479,7 @@
           <a:bodyPr wrap="square" lIns="0" tIns="0" rIns="0" bIns="0" rtlCol="0" anchor="ctr"/>
           <a:lstStyle/>
           <a:p>
-            <a:pPr indent="0" marL="0">
+            <a:pPr marL="0" indent="0">
               <a:buNone/>
             </a:pPr>
             <a:r>
@@ -5649,7 +5518,7 @@
           <a:bodyPr wrap="square" lIns="0" tIns="0" rIns="0" bIns="0" rtlCol="0" anchor="t"/>
           <a:lstStyle/>
           <a:p>
-            <a:pPr indent="0" marL="0">
+            <a:pPr marL="0" indent="0">
               <a:buNone/>
             </a:pPr>
             <a:r>
@@ -5730,7 +5599,7 @@
           <a:bodyPr wrap="square" lIns="0" tIns="0" rIns="0" bIns="0" rtlCol="0" anchor="ctr"/>
           <a:lstStyle/>
           <a:p>
-            <a:pPr indent="0" marL="0">
+            <a:pPr marL="0" indent="0">
               <a:buNone/>
             </a:pPr>
             <a:r>
@@ -5769,7 +5638,7 @@
           <a:bodyPr wrap="square" lIns="0" tIns="0" rIns="0" bIns="0" rtlCol="0" anchor="t"/>
           <a:lstStyle/>
           <a:p>
-            <a:pPr indent="0" marL="0">
+            <a:pPr marL="0" indent="0">
               <a:buNone/>
             </a:pPr>
             <a:r>
@@ -5850,7 +5719,7 @@
           <a:bodyPr wrap="square" lIns="0" tIns="0" rIns="0" bIns="0" rtlCol="0" anchor="ctr"/>
           <a:lstStyle/>
           <a:p>
-            <a:pPr indent="0" marL="0">
+            <a:pPr marL="0" indent="0">
               <a:buNone/>
             </a:pPr>
             <a:r>
@@ -5889,7 +5758,7 @@
           <a:bodyPr wrap="square" lIns="0" tIns="0" rIns="0" bIns="0" rtlCol="0" anchor="t"/>
           <a:lstStyle/>
           <a:p>
-            <a:pPr indent="0" marL="0">
+            <a:pPr marL="0" indent="0">
               <a:buNone/>
             </a:pPr>
             <a:r>
@@ -5923,6 +5792,7 @@
         <a:solidFill>
           <a:srgbClr val="FFFFFF"/>
         </a:solidFill>
+        <a:effectLst/>
       </p:bgPr>
     </p:bg>
     <p:spTree>
@@ -5941,55 +5811,7 @@
       </p:grpSpPr>
       <p:pic>
         <p:nvPicPr>
-          <p:cNvPr id="2" name="Image 0" descr="/home/claude/work/assets/logo_nit.jpeg">    </p:cNvPr>
-          <p:cNvPicPr>
-            <a:picLocks noChangeAspect="1"/>
-          </p:cNvPicPr>
-          <p:nvPr/>
-        </p:nvPicPr>
-        <p:blipFill>
-          <a:blip r:embed="rId1"/>
-          <a:stretch>
-            <a:fillRect/>
-          </a:stretch>
-        </p:blipFill>
-        <p:spPr>
-          <a:xfrm>
-            <a:off x="457200" y="256032"/>
-            <a:ext cx="822960" cy="822960"/>
-          </a:xfrm>
-          <a:prstGeom prst="rect">
-            <a:avLst/>
-          </a:prstGeom>
-        </p:spPr>
-      </p:pic>
-      <p:pic>
-        <p:nvPicPr>
-          <p:cNvPr id="3" name="Image 1" descr="/home/claude/work/assets/logo_codeverse.jpeg">    </p:cNvPr>
-          <p:cNvPicPr>
-            <a:picLocks noChangeAspect="1"/>
-          </p:cNvPicPr>
-          <p:nvPr/>
-        </p:nvPicPr>
-        <p:blipFill>
-          <a:blip r:embed="rId2"/>
-          <a:stretch>
-            <a:fillRect/>
-          </a:stretch>
-        </p:blipFill>
-        <p:spPr>
-          <a:xfrm>
-            <a:off x="5367528" y="109728"/>
-            <a:ext cx="1463040" cy="1188720"/>
-          </a:xfrm>
-          <a:prstGeom prst="rect">
-            <a:avLst/>
-          </a:prstGeom>
-        </p:spPr>
-      </p:pic>
-      <p:pic>
-        <p:nvPicPr>
-          <p:cNvPr id="4" name="Image 2" descr="/home/claude/work/assets/logo_up.jpeg">    </p:cNvPr>
+          <p:cNvPr id="2" name="Image 0" descr="/home/claude/work/assets/logo_nit.jpeg"/>
           <p:cNvPicPr>
             <a:picLocks noChangeAspect="1"/>
           </p:cNvPicPr>
@@ -6003,6 +5825,54 @@
         </p:blipFill>
         <p:spPr>
           <a:xfrm>
+            <a:off x="457200" y="256032"/>
+            <a:ext cx="822960" cy="822960"/>
+          </a:xfrm>
+          <a:prstGeom prst="rect">
+            <a:avLst/>
+          </a:prstGeom>
+        </p:spPr>
+      </p:pic>
+      <p:pic>
+        <p:nvPicPr>
+          <p:cNvPr id="3" name="Image 1" descr="/home/claude/work/assets/logo_codeverse.jpeg"/>
+          <p:cNvPicPr>
+            <a:picLocks noChangeAspect="1"/>
+          </p:cNvPicPr>
+          <p:nvPr/>
+        </p:nvPicPr>
+        <p:blipFill>
+          <a:blip r:embed="rId4"/>
+          <a:stretch>
+            <a:fillRect/>
+          </a:stretch>
+        </p:blipFill>
+        <p:spPr>
+          <a:xfrm>
+            <a:off x="5367528" y="109728"/>
+            <a:ext cx="1463040" cy="1188720"/>
+          </a:xfrm>
+          <a:prstGeom prst="rect">
+            <a:avLst/>
+          </a:prstGeom>
+        </p:spPr>
+      </p:pic>
+      <p:pic>
+        <p:nvPicPr>
+          <p:cNvPr id="4" name="Image 2" descr="/home/claude/work/assets/logo_up.jpeg"/>
+          <p:cNvPicPr>
+            <a:picLocks noChangeAspect="1"/>
+          </p:cNvPicPr>
+          <p:nvPr/>
+        </p:nvPicPr>
+        <p:blipFill>
+          <a:blip r:embed="rId5"/>
+          <a:stretch>
+            <a:fillRect/>
+          </a:stretch>
+        </p:blipFill>
+        <p:spPr>
+          <a:xfrm>
             <a:off x="10927080" y="292608"/>
             <a:ext cx="777240" cy="777240"/>
           </a:xfrm>
@@ -6072,7 +5942,7 @@
           <a:bodyPr wrap="square" lIns="0" tIns="0" rIns="0" bIns="0" rtlCol="0" anchor="ctr"/>
           <a:lstStyle/>
           <a:p>
-            <a:pPr algn="ctr" indent="0" marL="0">
+            <a:pPr marL="0" indent="0" algn="ctr">
               <a:buNone/>
             </a:pPr>
             <a:r>
@@ -6086,9 +5956,6 @@
               </a:rPr>
               <a:t>BUILD WITH  </a:t>
             </a:r>
-            <a:pPr algn="ctr" indent="0" marL="0">
-              <a:buNone/>
-            </a:pPr>
             <a:r>
               <a:rPr lang="en-US" sz="1000" b="1" dirty="0">
                 <a:solidFill>
@@ -6145,7 +6012,7 @@
           <a:bodyPr wrap="square" lIns="0" tIns="0" rIns="0" bIns="0" rtlCol="0" anchor="ctr"/>
           <a:lstStyle/>
           <a:p>
-            <a:pPr indent="0" marL="0">
+            <a:pPr marL="0" indent="0">
               <a:buNone/>
             </a:pPr>
             <a:r>
@@ -6208,7 +6075,7 @@
       </p:sp>
       <p:graphicFrame>
         <p:nvGraphicFramePr>
-          <p:cNvPr id="8" name="Table 0"/>
+          <p:cNvPr id="12" name="Table 0"/>
           <p:cNvGraphicFramePr>
             <a:graphicFrameLocks noGrp="1"/>
           </p:cNvGraphicFramePr>
@@ -6222,17 +6089,41 @@
         </p:nvGraphicFramePr>
         <p:xfrm>
           <a:off x="640080" y="1737360"/>
-          <a:ext cx="10881360" cy="1554480"/>
+          <a:ext cx="10872216" cy="1554480"/>
         </p:xfrm>
         <a:graphic>
           <a:graphicData uri="http://schemas.openxmlformats.org/drawingml/2006/table">
             <a:tbl>
               <a:tblPr/>
               <a:tblGrid>
-                <a:gridCol w="3931920"/>
-                <a:gridCol w="2313432"/>
-                <a:gridCol w="2313432"/>
-                <a:gridCol w="2313432"/>
+                <a:gridCol w="3931920">
+                  <a:extLst>
+                    <a:ext uri="{9D8B030D-6E8A-4147-A177-3AD203B41FA5}">
+                      <a16:colId xmlns:a16="http://schemas.microsoft.com/office/drawing/2014/main" val="20000"/>
+                    </a:ext>
+                  </a:extLst>
+                </a:gridCol>
+                <a:gridCol w="2313432">
+                  <a:extLst>
+                    <a:ext uri="{9D8B030D-6E8A-4147-A177-3AD203B41FA5}">
+                      <a16:colId xmlns:a16="http://schemas.microsoft.com/office/drawing/2014/main" val="20001"/>
+                    </a:ext>
+                  </a:extLst>
+                </a:gridCol>
+                <a:gridCol w="2313432">
+                  <a:extLst>
+                    <a:ext uri="{9D8B030D-6E8A-4147-A177-3AD203B41FA5}">
+                      <a16:colId xmlns:a16="http://schemas.microsoft.com/office/drawing/2014/main" val="20002"/>
+                    </a:ext>
+                  </a:extLst>
+                </a:gridCol>
+                <a:gridCol w="2313432">
+                  <a:extLst>
+                    <a:ext uri="{9D8B030D-6E8A-4147-A177-3AD203B41FA5}">
+                      <a16:colId xmlns:a16="http://schemas.microsoft.com/office/drawing/2014/main" val="20003"/>
+                    </a:ext>
+                  </a:extLst>
+                </a:gridCol>
               </a:tblGrid>
               <a:tr h="310896">
                 <a:tc>
@@ -6240,7 +6131,7 @@
                     <a:bodyPr/>
                     <a:lstStyle/>
                     <a:p>
-                      <a:pPr algn="ctr" indent="0" marL="0">
+                      <a:pPr marL="0" indent="0" algn="ctr">
                         <a:buNone/>
                       </a:pPr>
                       <a:r>
@@ -6254,7 +6145,7 @@
                       <a:endParaRPr lang="en-US" sz="1200" dirty="0"/>
                     </a:p>
                   </a:txBody>
-                  <a:tcPr marL="91440" marR="91440" marT="45720" marB="45720">
+                  <a:tcPr>
                     <a:lnL w="9525" cap="flat" cmpd="sng" algn="ctr">
                       <a:solidFill>
                         <a:srgbClr val="E0E0E0"/>
@@ -6301,7 +6192,7 @@
                     <a:bodyPr/>
                     <a:lstStyle/>
                     <a:p>
-                      <a:pPr algn="ctr" indent="0" marL="0">
+                      <a:pPr marL="0" indent="0" algn="ctr">
                         <a:buNone/>
                       </a:pPr>
                       <a:r>
@@ -6315,7 +6206,7 @@
                       <a:endParaRPr lang="en-US" sz="1200" dirty="0"/>
                     </a:p>
                   </a:txBody>
-                  <a:tcPr marL="91440" marR="91440" marT="45720" marB="45720">
+                  <a:tcPr>
                     <a:lnL w="9525" cap="flat" cmpd="sng" algn="ctr">
                       <a:solidFill>
                         <a:srgbClr val="E0E0E0"/>
@@ -6362,7 +6253,7 @@
                     <a:bodyPr/>
                     <a:lstStyle/>
                     <a:p>
-                      <a:pPr algn="ctr" indent="0" marL="0">
+                      <a:pPr marL="0" indent="0" algn="ctr">
                         <a:buNone/>
                       </a:pPr>
                       <a:r>
@@ -6376,7 +6267,7 @@
                       <a:endParaRPr lang="en-US" sz="1200" dirty="0"/>
                     </a:p>
                   </a:txBody>
-                  <a:tcPr marL="91440" marR="91440" marT="45720" marB="45720">
+                  <a:tcPr>
                     <a:lnL w="9525" cap="flat" cmpd="sng" algn="ctr">
                       <a:solidFill>
                         <a:srgbClr val="E0E0E0"/>
@@ -6423,7 +6314,7 @@
                     <a:bodyPr/>
                     <a:lstStyle/>
                     <a:p>
-                      <a:pPr algn="ctr" indent="0" marL="0">
+                      <a:pPr marL="0" indent="0" algn="ctr">
                         <a:buNone/>
                       </a:pPr>
                       <a:r>
@@ -6437,7 +6328,7 @@
                       <a:endParaRPr lang="en-US" sz="1200" dirty="0"/>
                     </a:p>
                   </a:txBody>
-                  <a:tcPr marL="91440" marR="91440" marT="45720" marB="45720">
+                  <a:tcPr>
                     <a:lnL w="9525" cap="flat" cmpd="sng" algn="ctr">
                       <a:solidFill>
                         <a:srgbClr val="E0E0E0"/>
@@ -6479,6 +6370,11 @@
                     </a:solidFill>
                   </a:tcPr>
                 </a:tc>
+                <a:extLst>
+                  <a:ext uri="{0D108BD9-81ED-4DB2-BD59-A6C34878D82A}">
+                    <a16:rowId xmlns:a16="http://schemas.microsoft.com/office/drawing/2014/main" val="10000"/>
+                  </a:ext>
+                </a:extLst>
               </a:tr>
               <a:tr h="310896">
                 <a:tc>
@@ -6486,7 +6382,7 @@
                     <a:bodyPr/>
                     <a:lstStyle/>
                     <a:p>
-                      <a:pPr algn="l" indent="0" marL="0">
+                      <a:pPr marL="0" indent="0" algn="l">
                         <a:buNone/>
                       </a:pPr>
                       <a:r>
@@ -6500,7 +6396,7 @@
                       <a:endParaRPr lang="en-US" sz="1200" dirty="0"/>
                     </a:p>
                   </a:txBody>
-                  <a:tcPr marL="91440" marR="91440" marT="45720" marB="45720">
+                  <a:tcPr>
                     <a:lnL w="9525" cap="flat" cmpd="sng" algn="ctr">
                       <a:solidFill>
                         <a:srgbClr val="E0E0E0"/>
@@ -6547,7 +6443,7 @@
                     <a:bodyPr/>
                     <a:lstStyle/>
                     <a:p>
-                      <a:pPr algn="ctr" indent="0" marL="0">
+                      <a:pPr marL="0" indent="0" algn="ctr">
                         <a:buNone/>
                       </a:pPr>
                       <a:r>
@@ -6561,7 +6457,7 @@
                       <a:endParaRPr lang="en-US" sz="1200" dirty="0"/>
                     </a:p>
                   </a:txBody>
-                  <a:tcPr marL="91440" marR="91440" marT="45720" marB="45720">
+                  <a:tcPr>
                     <a:lnL w="9525" cap="flat" cmpd="sng" algn="ctr">
                       <a:solidFill>
                         <a:srgbClr val="E0E0E0"/>
@@ -6608,7 +6504,7 @@
                     <a:bodyPr/>
                     <a:lstStyle/>
                     <a:p>
-                      <a:pPr algn="ctr" indent="0" marL="0">
+                      <a:pPr marL="0" indent="0" algn="ctr">
                         <a:buNone/>
                       </a:pPr>
                       <a:r>
@@ -6622,7 +6518,7 @@
                       <a:endParaRPr lang="en-US" sz="1200" dirty="0"/>
                     </a:p>
                   </a:txBody>
-                  <a:tcPr marL="91440" marR="91440" marT="45720" marB="45720">
+                  <a:tcPr>
                     <a:lnL w="9525" cap="flat" cmpd="sng" algn="ctr">
                       <a:solidFill>
                         <a:srgbClr val="E0E0E0"/>
@@ -6669,7 +6565,7 @@
                     <a:bodyPr/>
                     <a:lstStyle/>
                     <a:p>
-                      <a:pPr algn="ctr" indent="0" marL="0">
+                      <a:pPr marL="0" indent="0" algn="ctr">
                         <a:buNone/>
                       </a:pPr>
                       <a:r>
@@ -6683,7 +6579,7 @@
                       <a:endParaRPr lang="en-US" sz="1200" dirty="0"/>
                     </a:p>
                   </a:txBody>
-                  <a:tcPr marL="91440" marR="91440" marT="45720" marB="45720">
+                  <a:tcPr>
                     <a:lnL w="9525" cap="flat" cmpd="sng" algn="ctr">
                       <a:solidFill>
                         <a:srgbClr val="E0E0E0"/>
@@ -6725,6 +6621,11 @@
                     </a:solidFill>
                   </a:tcPr>
                 </a:tc>
+                <a:extLst>
+                  <a:ext uri="{0D108BD9-81ED-4DB2-BD59-A6C34878D82A}">
+                    <a16:rowId xmlns:a16="http://schemas.microsoft.com/office/drawing/2014/main" val="10001"/>
+                  </a:ext>
+                </a:extLst>
               </a:tr>
               <a:tr h="310896">
                 <a:tc>
@@ -6732,7 +6633,7 @@
                     <a:bodyPr/>
                     <a:lstStyle/>
                     <a:p>
-                      <a:pPr algn="l" indent="0" marL="0">
+                      <a:pPr marL="0" indent="0" algn="l">
                         <a:buNone/>
                       </a:pPr>
                       <a:r>
@@ -6746,7 +6647,7 @@
                       <a:endParaRPr lang="en-US" sz="1200" dirty="0"/>
                     </a:p>
                   </a:txBody>
-                  <a:tcPr marL="91440" marR="91440" marT="45720" marB="45720">
+                  <a:tcPr>
                     <a:lnL w="9525" cap="flat" cmpd="sng" algn="ctr">
                       <a:solidFill>
                         <a:srgbClr val="E0E0E0"/>
@@ -6793,7 +6694,7 @@
                     <a:bodyPr/>
                     <a:lstStyle/>
                     <a:p>
-                      <a:pPr algn="ctr" indent="0" marL="0">
+                      <a:pPr marL="0" indent="0" algn="ctr">
                         <a:buNone/>
                       </a:pPr>
                       <a:r>
@@ -6807,7 +6708,7 @@
                       <a:endParaRPr lang="en-US" sz="1200" dirty="0"/>
                     </a:p>
                   </a:txBody>
-                  <a:tcPr marL="91440" marR="91440" marT="45720" marB="45720">
+                  <a:tcPr>
                     <a:lnL w="9525" cap="flat" cmpd="sng" algn="ctr">
                       <a:solidFill>
                         <a:srgbClr val="E0E0E0"/>
@@ -6854,7 +6755,7 @@
                     <a:bodyPr/>
                     <a:lstStyle/>
                     <a:p>
-                      <a:pPr algn="ctr" indent="0" marL="0">
+                      <a:pPr marL="0" indent="0" algn="ctr">
                         <a:buNone/>
                       </a:pPr>
                       <a:r>
@@ -6868,7 +6769,7 @@
                       <a:endParaRPr lang="en-US" sz="1200" dirty="0"/>
                     </a:p>
                   </a:txBody>
-                  <a:tcPr marL="91440" marR="91440" marT="45720" marB="45720">
+                  <a:tcPr>
                     <a:lnL w="9525" cap="flat" cmpd="sng" algn="ctr">
                       <a:solidFill>
                         <a:srgbClr val="E0E0E0"/>
@@ -6915,7 +6816,7 @@
                     <a:bodyPr/>
                     <a:lstStyle/>
                     <a:p>
-                      <a:pPr algn="ctr" indent="0" marL="0">
+                      <a:pPr marL="0" indent="0" algn="ctr">
                         <a:buNone/>
                       </a:pPr>
                       <a:r>
@@ -6929,7 +6830,7 @@
                       <a:endParaRPr lang="en-US" sz="1200" dirty="0"/>
                     </a:p>
                   </a:txBody>
-                  <a:tcPr marL="91440" marR="91440" marT="45720" marB="45720">
+                  <a:tcPr>
                     <a:lnL w="9525" cap="flat" cmpd="sng" algn="ctr">
                       <a:solidFill>
                         <a:srgbClr val="E0E0E0"/>
@@ -6971,6 +6872,11 @@
                     </a:solidFill>
                   </a:tcPr>
                 </a:tc>
+                <a:extLst>
+                  <a:ext uri="{0D108BD9-81ED-4DB2-BD59-A6C34878D82A}">
+                    <a16:rowId xmlns:a16="http://schemas.microsoft.com/office/drawing/2014/main" val="10002"/>
+                  </a:ext>
+                </a:extLst>
               </a:tr>
               <a:tr h="310896">
                 <a:tc>
@@ -6978,7 +6884,7 @@
                     <a:bodyPr/>
                     <a:lstStyle/>
                     <a:p>
-                      <a:pPr algn="l" indent="0" marL="0">
+                      <a:pPr marL="0" indent="0" algn="l">
                         <a:buNone/>
                       </a:pPr>
                       <a:r>
@@ -6992,7 +6898,7 @@
                       <a:endParaRPr lang="en-US" sz="1200" dirty="0"/>
                     </a:p>
                   </a:txBody>
-                  <a:tcPr marL="91440" marR="91440" marT="45720" marB="45720">
+                  <a:tcPr>
                     <a:lnL w="9525" cap="flat" cmpd="sng" algn="ctr">
                       <a:solidFill>
                         <a:srgbClr val="E0E0E0"/>
@@ -7039,7 +6945,7 @@
                     <a:bodyPr/>
                     <a:lstStyle/>
                     <a:p>
-                      <a:pPr algn="ctr" indent="0" marL="0">
+                      <a:pPr marL="0" indent="0" algn="ctr">
                         <a:buNone/>
                       </a:pPr>
                       <a:r>
@@ -7053,7 +6959,7 @@
                       <a:endParaRPr lang="en-US" sz="1200" dirty="0"/>
                     </a:p>
                   </a:txBody>
-                  <a:tcPr marL="91440" marR="91440" marT="45720" marB="45720">
+                  <a:tcPr>
                     <a:lnL w="9525" cap="flat" cmpd="sng" algn="ctr">
                       <a:solidFill>
                         <a:srgbClr val="E0E0E0"/>
@@ -7100,7 +7006,7 @@
                     <a:bodyPr/>
                     <a:lstStyle/>
                     <a:p>
-                      <a:pPr algn="ctr" indent="0" marL="0">
+                      <a:pPr marL="0" indent="0" algn="ctr">
                         <a:buNone/>
                       </a:pPr>
                       <a:r>
@@ -7114,7 +7020,7 @@
                       <a:endParaRPr lang="en-US" sz="1200" dirty="0"/>
                     </a:p>
                   </a:txBody>
-                  <a:tcPr marL="91440" marR="91440" marT="45720" marB="45720">
+                  <a:tcPr>
                     <a:lnL w="9525" cap="flat" cmpd="sng" algn="ctr">
                       <a:solidFill>
                         <a:srgbClr val="E0E0E0"/>
@@ -7161,7 +7067,7 @@
                     <a:bodyPr/>
                     <a:lstStyle/>
                     <a:p>
-                      <a:pPr algn="ctr" indent="0" marL="0">
+                      <a:pPr marL="0" indent="0" algn="ctr">
                         <a:buNone/>
                       </a:pPr>
                       <a:r>
@@ -7175,7 +7081,7 @@
                       <a:endParaRPr lang="en-US" sz="1200" dirty="0"/>
                     </a:p>
                   </a:txBody>
-                  <a:tcPr marL="91440" marR="91440" marT="45720" marB="45720">
+                  <a:tcPr>
                     <a:lnL w="9525" cap="flat" cmpd="sng" algn="ctr">
                       <a:solidFill>
                         <a:srgbClr val="E0E0E0"/>
@@ -7217,6 +7123,11 @@
                     </a:solidFill>
                   </a:tcPr>
                 </a:tc>
+                <a:extLst>
+                  <a:ext uri="{0D108BD9-81ED-4DB2-BD59-A6C34878D82A}">
+                    <a16:rowId xmlns:a16="http://schemas.microsoft.com/office/drawing/2014/main" val="10003"/>
+                  </a:ext>
+                </a:extLst>
               </a:tr>
               <a:tr h="310896">
                 <a:tc>
@@ -7224,7 +7135,7 @@
                     <a:bodyPr/>
                     <a:lstStyle/>
                     <a:p>
-                      <a:pPr algn="l" indent="0" marL="0">
+                      <a:pPr marL="0" indent="0" algn="l">
                         <a:buNone/>
                       </a:pPr>
                       <a:r>
@@ -7238,7 +7149,7 @@
                       <a:endParaRPr lang="en-US" sz="1200" dirty="0"/>
                     </a:p>
                   </a:txBody>
-                  <a:tcPr marL="91440" marR="91440" marT="45720" marB="45720">
+                  <a:tcPr>
                     <a:lnL w="9525" cap="flat" cmpd="sng" algn="ctr">
                       <a:solidFill>
                         <a:srgbClr val="E0E0E0"/>
@@ -7285,7 +7196,7 @@
                     <a:bodyPr/>
                     <a:lstStyle/>
                     <a:p>
-                      <a:pPr algn="ctr" indent="0" marL="0">
+                      <a:pPr marL="0" indent="0" algn="ctr">
                         <a:buNone/>
                       </a:pPr>
                       <a:r>
@@ -7299,7 +7210,7 @@
                       <a:endParaRPr lang="en-US" sz="1200" dirty="0"/>
                     </a:p>
                   </a:txBody>
-                  <a:tcPr marL="91440" marR="91440" marT="45720" marB="45720">
+                  <a:tcPr>
                     <a:lnL w="9525" cap="flat" cmpd="sng" algn="ctr">
                       <a:solidFill>
                         <a:srgbClr val="E0E0E0"/>
@@ -7346,7 +7257,7 @@
                     <a:bodyPr/>
                     <a:lstStyle/>
                     <a:p>
-                      <a:pPr algn="ctr" indent="0" marL="0">
+                      <a:pPr marL="0" indent="0" algn="ctr">
                         <a:buNone/>
                       </a:pPr>
                       <a:r>
@@ -7360,7 +7271,7 @@
                       <a:endParaRPr lang="en-US" sz="1200" dirty="0"/>
                     </a:p>
                   </a:txBody>
-                  <a:tcPr marL="91440" marR="91440" marT="45720" marB="45720">
+                  <a:tcPr>
                     <a:lnL w="9525" cap="flat" cmpd="sng" algn="ctr">
                       <a:solidFill>
                         <a:srgbClr val="E0E0E0"/>
@@ -7407,7 +7318,7 @@
                     <a:bodyPr/>
                     <a:lstStyle/>
                     <a:p>
-                      <a:pPr algn="ctr" indent="0" marL="0">
+                      <a:pPr marL="0" indent="0" algn="ctr">
                         <a:buNone/>
                       </a:pPr>
                       <a:r>
@@ -7421,7 +7332,7 @@
                       <a:endParaRPr lang="en-US" sz="1200" dirty="0"/>
                     </a:p>
                   </a:txBody>
-                  <a:tcPr marL="91440" marR="91440" marT="45720" marB="45720">
+                  <a:tcPr>
                     <a:lnL w="9525" cap="flat" cmpd="sng" algn="ctr">
                       <a:solidFill>
                         <a:srgbClr val="E0E0E0"/>
@@ -7463,6 +7374,11 @@
                     </a:solidFill>
                   </a:tcPr>
                 </a:tc>
+                <a:extLst>
+                  <a:ext uri="{0D108BD9-81ED-4DB2-BD59-A6C34878D82A}">
+                    <a16:rowId xmlns:a16="http://schemas.microsoft.com/office/drawing/2014/main" val="10004"/>
+                  </a:ext>
+                </a:extLst>
               </a:tr>
             </a:tbl>
           </a:graphicData>
@@ -7489,7 +7405,7 @@
           <a:bodyPr wrap="square" lIns="0" tIns="0" rIns="0" bIns="0" rtlCol="0" anchor="ctr"/>
           <a:lstStyle/>
           <a:p>
-            <a:pPr indent="0" marL="0">
+            <a:pPr marL="0" indent="0">
               <a:buNone/>
             </a:pPr>
             <a:r>
@@ -7598,7 +7514,7 @@
           <a:bodyPr wrap="square" lIns="0" tIns="0" rIns="0" bIns="0" rtlCol="0" anchor="ctr"/>
           <a:lstStyle/>
           <a:p>
-            <a:pPr indent="0" marL="0">
+            <a:pPr marL="0" indent="0">
               <a:buNone/>
             </a:pPr>
             <a:r>
@@ -7702,6 +7618,7 @@
         <a:solidFill>
           <a:srgbClr val="FFFFFF"/>
         </a:solidFill>
+        <a:effectLst/>
       </p:bgPr>
     </p:bg>
     <p:spTree>
@@ -7720,55 +7637,7 @@
       </p:grpSpPr>
       <p:pic>
         <p:nvPicPr>
-          <p:cNvPr id="2" name="Image 0" descr="/home/claude/work/assets/logo_nit.jpeg">    </p:cNvPr>
-          <p:cNvPicPr>
-            <a:picLocks noChangeAspect="1"/>
-          </p:cNvPicPr>
-          <p:nvPr/>
-        </p:nvPicPr>
-        <p:blipFill>
-          <a:blip r:embed="rId1"/>
-          <a:stretch>
-            <a:fillRect/>
-          </a:stretch>
-        </p:blipFill>
-        <p:spPr>
-          <a:xfrm>
-            <a:off x="457200" y="256032"/>
-            <a:ext cx="822960" cy="822960"/>
-          </a:xfrm>
-          <a:prstGeom prst="rect">
-            <a:avLst/>
-          </a:prstGeom>
-        </p:spPr>
-      </p:pic>
-      <p:pic>
-        <p:nvPicPr>
-          <p:cNvPr id="3" name="Image 1" descr="/home/claude/work/assets/logo_codeverse.jpeg">    </p:cNvPr>
-          <p:cNvPicPr>
-            <a:picLocks noChangeAspect="1"/>
-          </p:cNvPicPr>
-          <p:nvPr/>
-        </p:nvPicPr>
-        <p:blipFill>
-          <a:blip r:embed="rId2"/>
-          <a:stretch>
-            <a:fillRect/>
-          </a:stretch>
-        </p:blipFill>
-        <p:spPr>
-          <a:xfrm>
-            <a:off x="5367528" y="109728"/>
-            <a:ext cx="1463040" cy="1188720"/>
-          </a:xfrm>
-          <a:prstGeom prst="rect">
-            <a:avLst/>
-          </a:prstGeom>
-        </p:spPr>
-      </p:pic>
-      <p:pic>
-        <p:nvPicPr>
-          <p:cNvPr id="4" name="Image 2" descr="/home/claude/work/assets/logo_up.jpeg">    </p:cNvPr>
+          <p:cNvPr id="2" name="Image 0" descr="/home/claude/work/assets/logo_nit.jpeg"/>
           <p:cNvPicPr>
             <a:picLocks noChangeAspect="1"/>
           </p:cNvPicPr>
@@ -7782,6 +7651,54 @@
         </p:blipFill>
         <p:spPr>
           <a:xfrm>
+            <a:off x="457200" y="256032"/>
+            <a:ext cx="822960" cy="822960"/>
+          </a:xfrm>
+          <a:prstGeom prst="rect">
+            <a:avLst/>
+          </a:prstGeom>
+        </p:spPr>
+      </p:pic>
+      <p:pic>
+        <p:nvPicPr>
+          <p:cNvPr id="3" name="Image 1" descr="/home/claude/work/assets/logo_codeverse.jpeg"/>
+          <p:cNvPicPr>
+            <a:picLocks noChangeAspect="1"/>
+          </p:cNvPicPr>
+          <p:nvPr/>
+        </p:nvPicPr>
+        <p:blipFill>
+          <a:blip r:embed="rId4"/>
+          <a:stretch>
+            <a:fillRect/>
+          </a:stretch>
+        </p:blipFill>
+        <p:spPr>
+          <a:xfrm>
+            <a:off x="5367528" y="109728"/>
+            <a:ext cx="1463040" cy="1188720"/>
+          </a:xfrm>
+          <a:prstGeom prst="rect">
+            <a:avLst/>
+          </a:prstGeom>
+        </p:spPr>
+      </p:pic>
+      <p:pic>
+        <p:nvPicPr>
+          <p:cNvPr id="4" name="Image 2" descr="/home/claude/work/assets/logo_up.jpeg"/>
+          <p:cNvPicPr>
+            <a:picLocks noChangeAspect="1"/>
+          </p:cNvPicPr>
+          <p:nvPr/>
+        </p:nvPicPr>
+        <p:blipFill>
+          <a:blip r:embed="rId5"/>
+          <a:stretch>
+            <a:fillRect/>
+          </a:stretch>
+        </p:blipFill>
+        <p:spPr>
+          <a:xfrm>
             <a:off x="10927080" y="292608"/>
             <a:ext cx="777240" cy="777240"/>
           </a:xfrm>
@@ -7851,7 +7768,7 @@
           <a:bodyPr wrap="square" lIns="0" tIns="0" rIns="0" bIns="0" rtlCol="0" anchor="ctr"/>
           <a:lstStyle/>
           <a:p>
-            <a:pPr algn="ctr" indent="0" marL="0">
+            <a:pPr marL="0" indent="0" algn="ctr">
               <a:buNone/>
             </a:pPr>
             <a:r>
@@ -7865,9 +7782,6 @@
               </a:rPr>
               <a:t>BUILD WITH  </a:t>
             </a:r>
-            <a:pPr algn="ctr" indent="0" marL="0">
-              <a:buNone/>
-            </a:pPr>
             <a:r>
               <a:rPr lang="en-US" sz="1000" b="1" dirty="0">
                 <a:solidFill>
@@ -7924,7 +7838,7 @@
           <a:bodyPr wrap="square" lIns="0" tIns="0" rIns="0" bIns="0" rtlCol="0" anchor="ctr"/>
           <a:lstStyle/>
           <a:p>
-            <a:pPr indent="0" marL="0">
+            <a:pPr marL="0" indent="0">
               <a:buNone/>
             </a:pPr>
             <a:r>
@@ -8006,7 +7920,7 @@
           <a:bodyPr wrap="square" lIns="0" tIns="0" rIns="0" bIns="0" rtlCol="0" anchor="ctr"/>
           <a:lstStyle/>
           <a:p>
-            <a:pPr indent="0" marL="0">
+            <a:pPr marL="0" indent="0">
               <a:buNone/>
             </a:pPr>
             <a:r>
@@ -8159,9 +8073,6 @@
           <a:bodyPr wrap="square" lIns="0" tIns="0" rIns="0" bIns="0" rtlCol="0" anchor="ctr"/>
           <a:lstStyle/>
           <a:p>
-            <a:pPr indent="0" marL="0">
-              <a:buNone/>
-            </a:pPr>
             <a:r>
               <a:rPr lang="en-US" sz="1400" b="1" dirty="0">
                 <a:solidFill>
@@ -8173,19 +8084,21 @@
               </a:rPr>
               <a:t>GitHub Repository:  </a:t>
             </a:r>
-            <a:pPr indent="0" marL="0">
-              <a:buNone/>
-            </a:pPr>
-            <a:r>
-              <a:rPr lang="en-US" sz="1400" i="1" dirty="0">
-                <a:solidFill>
-                  <a:srgbClr val="5A5A5A"/>
-                </a:solidFill>
-                <a:latin typeface="Arial" pitchFamily="34" charset="0"/>
-                <a:ea typeface="Arial" pitchFamily="34" charset="-122"/>
-                <a:cs typeface="Arial" pitchFamily="34" charset="-120"/>
-              </a:rPr>
-              <a:t>[Add your repo link here]</a:t>
+            <a:r>
+              <a:rPr lang="en-IN" sz="1400" dirty="0"/>
+              <a:t>github.com/</a:t>
+            </a:r>
+            <a:r>
+              <a:rPr lang="en-IN" sz="1400" dirty="0" err="1"/>
+              <a:t>amansinghrajput-asr</a:t>
+            </a:r>
+            <a:r>
+              <a:rPr lang="en-IN" sz="1400" dirty="0"/>
+              <a:t>/</a:t>
+            </a:r>
+            <a:r>
+              <a:rPr lang="en-IN" sz="1400" dirty="0" err="1"/>
+              <a:t>StrumSense</a:t>
             </a:r>
             <a:endParaRPr lang="en-US" sz="1400" dirty="0"/>
           </a:p>
@@ -8212,7 +8125,7 @@
           <a:bodyPr wrap="square" lIns="0" tIns="0" rIns="0" bIns="0" rtlCol="0" anchor="ctr"/>
           <a:lstStyle/>
           <a:p>
-            <a:pPr indent="0" marL="0">
+            <a:pPr marL="0" indent="0">
               <a:buNone/>
             </a:pPr>
             <a:r>
@@ -8226,9 +8139,6 @@
               </a:rPr>
               <a:t>Demo Video Link:  </a:t>
             </a:r>
-            <a:pPr indent="0" marL="0">
-              <a:buNone/>
-            </a:pPr>
             <a:r>
               <a:rPr lang="en-US" sz="1400" i="1" dirty="0">
                 <a:solidFill>
@@ -8265,7 +8175,7 @@
           <a:bodyPr wrap="square" lIns="0" tIns="0" rIns="0" bIns="0" rtlCol="0" anchor="ctr"/>
           <a:lstStyle/>
           <a:p>
-            <a:pPr algn="ctr" indent="0" marL="0">
+            <a:pPr marL="0" indent="0" algn="ctr">
               <a:buNone/>
             </a:pPr>
             <a:r>
@@ -8280,6 +8190,71 @@
               <a:t>Thank You!</a:t>
             </a:r>
             <a:endParaRPr lang="en-US" sz="2600" dirty="0"/>
+          </a:p>
+        </p:txBody>
+      </p:sp>
+      <p:pic>
+        <p:nvPicPr>
+          <p:cNvPr id="20" name="Picture 19">
+            <a:extLst>
+              <a:ext uri="{FF2B5EF4-FFF2-40B4-BE49-F238E27FC236}">
+                <a16:creationId xmlns:a16="http://schemas.microsoft.com/office/drawing/2014/main" id="{D6899AFB-00CC-1DF5-6B17-56C07E1147BE}"/>
+              </a:ext>
+            </a:extLst>
+          </p:cNvPr>
+          <p:cNvPicPr>
+            <a:picLocks noChangeAspect="1"/>
+          </p:cNvPicPr>
+          <p:nvPr/>
+        </p:nvPicPr>
+        <p:blipFill>
+          <a:blip r:embed="rId6"/>
+          <a:stretch>
+            <a:fillRect/>
+          </a:stretch>
+        </p:blipFill>
+        <p:spPr>
+          <a:xfrm>
+            <a:off x="9524999" y="3886200"/>
+            <a:ext cx="1623527" cy="1623527"/>
+          </a:xfrm>
+          <a:prstGeom prst="rect">
+            <a:avLst/>
+          </a:prstGeom>
+        </p:spPr>
+      </p:pic>
+      <p:sp>
+        <p:nvSpPr>
+          <p:cNvPr id="21" name="TextBox 20">
+            <a:extLst>
+              <a:ext uri="{FF2B5EF4-FFF2-40B4-BE49-F238E27FC236}">
+                <a16:creationId xmlns:a16="http://schemas.microsoft.com/office/drawing/2014/main" id="{1D0E17CE-03C1-56C2-A3AD-7B9BC9DFEF5A}"/>
+              </a:ext>
+            </a:extLst>
+          </p:cNvPr>
+          <p:cNvSpPr txBox="1"/>
+          <p:nvPr/>
+        </p:nvSpPr>
+        <p:spPr>
+          <a:xfrm>
+            <a:off x="9478034" y="5365183"/>
+            <a:ext cx="1837666" cy="369332"/>
+          </a:xfrm>
+          <a:prstGeom prst="rect">
+            <a:avLst/>
+          </a:prstGeom>
+          <a:noFill/>
+        </p:spPr>
+        <p:txBody>
+          <a:bodyPr wrap="square" rtlCol="0">
+            <a:spAutoFit/>
+          </a:bodyPr>
+          <a:lstStyle/>
+          <a:p>
+            <a:r>
+              <a:rPr lang="en-IN" dirty="0"/>
+              <a:t>Explore the Repo</a:t>
+            </a:r>
           </a:p>
         </p:txBody>
       </p:sp>
@@ -8584,4 +8559,319 @@
     </a:ext>
   </a:extLst>
 </a:theme>
+</file>
+
+<file path=ppt/theme/theme2.xml><?xml version="1.0" encoding="utf-8"?>
+<a:theme xmlns:a="http://schemas.openxmlformats.org/drawingml/2006/main" name="Office Theme">
+  <a:themeElements>
+    <a:clrScheme name="Office">
+      <a:dk1>
+        <a:sysClr val="windowText" lastClr="000000"/>
+      </a:dk1>
+      <a:lt1>
+        <a:sysClr val="window" lastClr="FFFFFF"/>
+      </a:lt1>
+      <a:dk2>
+        <a:srgbClr val="0E2841"/>
+      </a:dk2>
+      <a:lt2>
+        <a:srgbClr val="E8E8E8"/>
+      </a:lt2>
+      <a:accent1>
+        <a:srgbClr val="156082"/>
+      </a:accent1>
+      <a:accent2>
+        <a:srgbClr val="E97132"/>
+      </a:accent2>
+      <a:accent3>
+        <a:srgbClr val="196B24"/>
+      </a:accent3>
+      <a:accent4>
+        <a:srgbClr val="0F9ED5"/>
+      </a:accent4>
+      <a:accent5>
+        <a:srgbClr val="A02B93"/>
+      </a:accent5>
+      <a:accent6>
+        <a:srgbClr val="4EA72E"/>
+      </a:accent6>
+      <a:hlink>
+        <a:srgbClr val="467886"/>
+      </a:hlink>
+      <a:folHlink>
+        <a:srgbClr val="96607D"/>
+      </a:folHlink>
+    </a:clrScheme>
+    <a:fontScheme name="Office">
+      <a:majorFont>
+        <a:latin typeface="Aptos Display" panose="02110004020202020204"/>
+        <a:ea typeface=""/>
+        <a:cs typeface=""/>
+        <a:font script="Jpan" typeface="游ゴシック Light"/>
+        <a:font script="Hang" typeface="맑은 고딕"/>
+        <a:font script="Hans" typeface="等线 Light"/>
+        <a:font script="Hant" typeface="新細明體"/>
+        <a:font script="Arab" typeface="Times New Roman"/>
+        <a:font script="Hebr" typeface="Times New Roman"/>
+        <a:font script="Thai" typeface="Angsana New"/>
+        <a:font script="Ethi" typeface="Nyala"/>
+        <a:font script="Beng" typeface="Vrinda"/>
+        <a:font script="Gujr" typeface="Shruti"/>
+        <a:font script="Khmr" typeface="MoolBoran"/>
+        <a:font script="Knda" typeface="Tunga"/>
+        <a:font script="Guru" typeface="Raavi"/>
+        <a:font script="Cans" typeface="Euphemia"/>
+        <a:font script="Cher" typeface="Plantagenet Cherokee"/>
+        <a:font script="Yiii" typeface="Microsoft Yi Baiti"/>
+        <a:font script="Tibt" typeface="Microsoft Himalaya"/>
+        <a:font script="Thaa" typeface="MV Boli"/>
+        <a:font script="Deva" typeface="Mangal"/>
+        <a:font script="Telu" typeface="Gautami"/>
+        <a:font script="Taml" typeface="Latha"/>
+        <a:font script="Syrc" typeface="Estrangelo Edessa"/>
+        <a:font script="Orya" typeface="Kalinga"/>
+        <a:font script="Mlym" typeface="Kartika"/>
+        <a:font script="Laoo" typeface="DokChampa"/>
+        <a:font script="Sinh" typeface="Iskoola Pota"/>
+        <a:font script="Mong" typeface="Mongolian Baiti"/>
+        <a:font script="Viet" typeface="Times New Roman"/>
+        <a:font script="Uigh" typeface="Microsoft Uighur"/>
+        <a:font script="Geor" typeface="Sylfaen"/>
+        <a:font script="Armn" typeface="Arial"/>
+        <a:font script="Bugi" typeface="Leelawadee UI"/>
+        <a:font script="Bopo" typeface="Microsoft JhengHei"/>
+        <a:font script="Java" typeface="Javanese Text"/>
+        <a:font script="Lisu" typeface="Segoe UI"/>
+        <a:font script="Mymr" typeface="Myanmar Text"/>
+        <a:font script="Nkoo" typeface="Ebrima"/>
+        <a:font script="Olck" typeface="Nirmala UI"/>
+        <a:font script="Osma" typeface="Ebrima"/>
+        <a:font script="Phag" typeface="Phagspa"/>
+        <a:font script="Syrn" typeface="Estrangelo Edessa"/>
+        <a:font script="Syrj" typeface="Estrangelo Edessa"/>
+        <a:font script="Syre" typeface="Estrangelo Edessa"/>
+        <a:font script="Sora" typeface="Nirmala UI"/>
+        <a:font script="Tale" typeface="Microsoft Tai Le"/>
+        <a:font script="Talu" typeface="Microsoft New Tai Lue"/>
+        <a:font script="Tfng" typeface="Ebrima"/>
+      </a:majorFont>
+      <a:minorFont>
+        <a:latin typeface="Aptos" panose="02110004020202020204"/>
+        <a:ea typeface=""/>
+        <a:cs typeface=""/>
+        <a:font script="Jpan" typeface="游ゴシック"/>
+        <a:font script="Hang" typeface="맑은 고딕"/>
+        <a:font script="Hans" typeface="等线"/>
+        <a:font script="Hant" typeface="新細明體"/>
+        <a:font script="Arab" typeface="Arial"/>
+        <a:font script="Hebr" typeface="Arial"/>
+        <a:font script="Thai" typeface="Cordia New"/>
+        <a:font script="Ethi" typeface="Nyala"/>
+        <a:font script="Beng" typeface="Vrinda"/>
+        <a:font script="Gujr" typeface="Shruti"/>
+        <a:font script="Khmr" typeface="DaunPenh"/>
+        <a:font script="Knda" typeface="Tunga"/>
+        <a:font script="Guru" typeface="Raavi"/>
+        <a:font script="Cans" typeface="Euphemia"/>
+        <a:font script="Cher" typeface="Plantagenet Cherokee"/>
+        <a:font script="Yiii" typeface="Microsoft Yi Baiti"/>
+        <a:font script="Tibt" typeface="Microsoft Himalaya"/>
+        <a:font script="Thaa" typeface="MV Boli"/>
+        <a:font script="Deva" typeface="Mangal"/>
+        <a:font script="Telu" typeface="Gautami"/>
+        <a:font script="Taml" typeface="Latha"/>
+        <a:font script="Syrc" typeface="Estrangelo Edessa"/>
+        <a:font script="Orya" typeface="Kalinga"/>
+        <a:font script="Mlym" typeface="Kartika"/>
+        <a:font script="Laoo" typeface="DokChampa"/>
+        <a:font script="Sinh" typeface="Iskoola Pota"/>
+        <a:font script="Mong" typeface="Mongolian Baiti"/>
+        <a:font script="Viet" typeface="Arial"/>
+        <a:font script="Uigh" typeface="Microsoft Uighur"/>
+        <a:font script="Geor" typeface="Sylfaen"/>
+        <a:font script="Armn" typeface="Arial"/>
+        <a:font script="Bugi" typeface="Leelawadee UI"/>
+        <a:font script="Bopo" typeface="Microsoft JhengHei"/>
+        <a:font script="Java" typeface="Javanese Text"/>
+        <a:font script="Lisu" typeface="Segoe UI"/>
+        <a:font script="Mymr" typeface="Myanmar Text"/>
+        <a:font script="Nkoo" typeface="Ebrima"/>
+        <a:font script="Olck" typeface="Nirmala UI"/>
+        <a:font script="Osma" typeface="Ebrima"/>
+        <a:font script="Phag" typeface="Phagspa"/>
+        <a:font script="Syrn" typeface="Estrangelo Edessa"/>
+        <a:font script="Syrj" typeface="Estrangelo Edessa"/>
+        <a:font script="Syre" typeface="Estrangelo Edessa"/>
+        <a:font script="Sora" typeface="Nirmala UI"/>
+        <a:font script="Tale" typeface="Microsoft Tai Le"/>
+        <a:font script="Talu" typeface="Microsoft New Tai Lue"/>
+        <a:font script="Tfng" typeface="Ebrima"/>
+      </a:minorFont>
+    </a:fontScheme>
+    <a:fmtScheme name="Office">
+      <a:fillStyleLst>
+        <a:solidFill>
+          <a:schemeClr val="phClr"/>
+        </a:solidFill>
+        <a:gradFill rotWithShape="1">
+          <a:gsLst>
+            <a:gs pos="0">
+              <a:schemeClr val="phClr">
+                <a:lumMod val="110000"/>
+                <a:satMod val="105000"/>
+                <a:tint val="67000"/>
+              </a:schemeClr>
+            </a:gs>
+            <a:gs pos="50000">
+              <a:schemeClr val="phClr">
+                <a:lumMod val="105000"/>
+                <a:satMod val="103000"/>
+                <a:tint val="73000"/>
+              </a:schemeClr>
+            </a:gs>
+            <a:gs pos="100000">
+              <a:schemeClr val="phClr">
+                <a:lumMod val="105000"/>
+                <a:satMod val="109000"/>
+                <a:tint val="81000"/>
+              </a:schemeClr>
+            </a:gs>
+          </a:gsLst>
+          <a:lin ang="5400000" scaled="0"/>
+        </a:gradFill>
+        <a:gradFill rotWithShape="1">
+          <a:gsLst>
+            <a:gs pos="0">
+              <a:schemeClr val="phClr">
+                <a:satMod val="103000"/>
+                <a:lumMod val="102000"/>
+                <a:tint val="94000"/>
+              </a:schemeClr>
+            </a:gs>
+            <a:gs pos="50000">
+              <a:schemeClr val="phClr">
+                <a:satMod val="110000"/>
+                <a:lumMod val="100000"/>
+                <a:shade val="100000"/>
+              </a:schemeClr>
+            </a:gs>
+            <a:gs pos="100000">
+              <a:schemeClr val="phClr">
+                <a:lumMod val="99000"/>
+                <a:satMod val="120000"/>
+                <a:shade val="78000"/>
+              </a:schemeClr>
+            </a:gs>
+          </a:gsLst>
+          <a:lin ang="5400000" scaled="0"/>
+        </a:gradFill>
+      </a:fillStyleLst>
+      <a:lnStyleLst>
+        <a:ln w="12700" cap="flat" cmpd="sng" algn="ctr">
+          <a:solidFill>
+            <a:schemeClr val="phClr"/>
+          </a:solidFill>
+          <a:prstDash val="solid"/>
+          <a:miter lim="800000"/>
+        </a:ln>
+        <a:ln w="19050" cap="flat" cmpd="sng" algn="ctr">
+          <a:solidFill>
+            <a:schemeClr val="phClr"/>
+          </a:solidFill>
+          <a:prstDash val="solid"/>
+          <a:miter lim="800000"/>
+        </a:ln>
+        <a:ln w="25400" cap="flat" cmpd="sng" algn="ctr">
+          <a:solidFill>
+            <a:schemeClr val="phClr"/>
+          </a:solidFill>
+          <a:prstDash val="solid"/>
+          <a:miter lim="800000"/>
+        </a:ln>
+      </a:lnStyleLst>
+      <a:effectStyleLst>
+        <a:effectStyle>
+          <a:effectLst/>
+        </a:effectStyle>
+        <a:effectStyle>
+          <a:effectLst/>
+        </a:effectStyle>
+        <a:effectStyle>
+          <a:effectLst>
+            <a:outerShdw blurRad="57150" dist="19050" dir="5400000" algn="ctr" rotWithShape="0">
+              <a:srgbClr val="000000">
+                <a:alpha val="63000"/>
+              </a:srgbClr>
+            </a:outerShdw>
+          </a:effectLst>
+        </a:effectStyle>
+      </a:effectStyleLst>
+      <a:bgFillStyleLst>
+        <a:solidFill>
+          <a:schemeClr val="phClr"/>
+        </a:solidFill>
+        <a:solidFill>
+          <a:schemeClr val="phClr">
+            <a:tint val="95000"/>
+            <a:satMod val="170000"/>
+          </a:schemeClr>
+        </a:solidFill>
+        <a:gradFill rotWithShape="1">
+          <a:gsLst>
+            <a:gs pos="0">
+              <a:schemeClr val="phClr">
+                <a:tint val="93000"/>
+                <a:satMod val="150000"/>
+                <a:shade val="98000"/>
+                <a:lumMod val="102000"/>
+              </a:schemeClr>
+            </a:gs>
+            <a:gs pos="50000">
+              <a:schemeClr val="phClr">
+                <a:tint val="98000"/>
+                <a:satMod val="130000"/>
+                <a:shade val="90000"/>
+                <a:lumMod val="103000"/>
+              </a:schemeClr>
+            </a:gs>
+            <a:gs pos="100000">
+              <a:schemeClr val="phClr">
+                <a:shade val="63000"/>
+                <a:satMod val="120000"/>
+              </a:schemeClr>
+            </a:gs>
+          </a:gsLst>
+          <a:lin ang="5400000" scaled="0"/>
+        </a:gradFill>
+      </a:bgFillStyleLst>
+    </a:fmtScheme>
+  </a:themeElements>
+  <a:objectDefaults>
+    <a:lnDef>
+      <a:spPr/>
+      <a:bodyPr/>
+      <a:lstStyle/>
+      <a:style>
+        <a:lnRef idx="2">
+          <a:schemeClr val="accent1"/>
+        </a:lnRef>
+        <a:fillRef idx="0">
+          <a:schemeClr val="accent1"/>
+        </a:fillRef>
+        <a:effectRef idx="1">
+          <a:schemeClr val="accent1"/>
+        </a:effectRef>
+        <a:fontRef idx="minor">
+          <a:schemeClr val="tx1"/>
+        </a:fontRef>
+      </a:style>
+    </a:lnDef>
+  </a:objectDefaults>
+  <a:extraClrSchemeLst/>
+  <a:extLst>
+    <a:ext uri="{05A4C25C-085E-4340-85A3-A5531E510DB2}">
+      <thm15:themeFamily xmlns:thm15="http://schemas.microsoft.com/office/thememl/2012/main" name="Office Theme" id="{2E142A2C-CD16-42D6-873A-C26D2A0506FA}" vid="{1BDDFF52-6CD6-40A5-AB3C-68EB2F1E4D0A}"/>
+    </a:ext>
+  </a:extLst>
+</a:theme>
 </file>
</xml_diff>

<commit_message>
Added demo video link to presentation
</commit_message>
<xml_diff>
--- a/StrumSense_Build_with_Bharat_2.0.pptx
+++ b/StrumSense_Build_with_Bharat_2.0.pptx
@@ -122,7 +122,7 @@
 <file path=ppt/revisionInfo.xml><?xml version="1.0" encoding="utf-8"?>
 <p1510:revInfo xmlns:a="http://schemas.openxmlformats.org/drawingml/2006/main" xmlns:r="http://schemas.openxmlformats.org/officeDocument/2006/relationships" xmlns:p1510="http://schemas.microsoft.com/office/powerpoint/2015/10/main">
   <p1510:revLst>
-    <p1510:client id="{0B2C4BBF-9ACF-428D-8BFB-1B70B47D1A4F}" v="13" dt="2026-09-01T11:28:32.825"/>
+    <p1510:client id="{0B2C4BBF-9ACF-428D-8BFB-1B70B47D1A4F}" v="14" dt="2026-09-01T13:17:13.048"/>
   </p1510:revLst>
 </p1510:revInfo>
 </file>
@@ -132,7 +132,7 @@
   <pc:docChgLst>
     <pc:chgData name="Aman Singh" userId="59ab53f7b0af5e8b" providerId="LiveId" clId="{9E36CD2A-74E6-40E8-A8E9-578E1CDB348B}"/>
     <pc:docChg chg="undo custSel modSld">
-      <pc:chgData name="Aman Singh" userId="59ab53f7b0af5e8b" providerId="LiveId" clId="{9E36CD2A-74E6-40E8-A8E9-578E1CDB348B}" dt="2026-09-01T11:30:09.100" v="327" actId="20577"/>
+      <pc:chgData name="Aman Singh" userId="59ab53f7b0af5e8b" providerId="LiveId" clId="{9E36CD2A-74E6-40E8-A8E9-578E1CDB348B}" dt="2026-09-01T13:17:31.846" v="358" actId="113"/>
       <pc:docMkLst>
         <pc:docMk/>
       </pc:docMkLst>
@@ -183,7 +183,7 @@
         </pc:spChg>
       </pc:sldChg>
       <pc:sldChg chg="addSp delSp modSp mod">
-        <pc:chgData name="Aman Singh" userId="59ab53f7b0af5e8b" providerId="LiveId" clId="{9E36CD2A-74E6-40E8-A8E9-578E1CDB348B}" dt="2026-08-29T05:29:40.957" v="99" actId="20577"/>
+        <pc:chgData name="Aman Singh" userId="59ab53f7b0af5e8b" providerId="LiveId" clId="{9E36CD2A-74E6-40E8-A8E9-578E1CDB348B}" dt="2026-09-01T13:17:31.846" v="358" actId="113"/>
         <pc:sldMkLst>
           <pc:docMk/>
           <pc:sldMk cId="0" sldId="263"/>
@@ -194,6 +194,14 @@
             <pc:docMk/>
             <pc:sldMk cId="0" sldId="263"/>
             <ac:spMk id="15" creationId="{00000000-0000-0000-0000-000000000000}"/>
+          </ac:spMkLst>
+        </pc:spChg>
+        <pc:spChg chg="mod">
+          <ac:chgData name="Aman Singh" userId="59ab53f7b0af5e8b" providerId="LiveId" clId="{9E36CD2A-74E6-40E8-A8E9-578E1CDB348B}" dt="2026-09-01T13:17:31.846" v="358" actId="113"/>
+          <ac:spMkLst>
+            <pc:docMk/>
+            <pc:sldMk cId="0" sldId="263"/>
+            <ac:spMk id="16" creationId="{00000000-0000-0000-0000-000000000000}"/>
           </ac:spMkLst>
         </pc:spChg>
         <pc:spChg chg="add mod">
@@ -8112,7 +8120,7 @@
         </p:nvSpPr>
         <p:spPr>
           <a:xfrm>
-            <a:off x="640080" y="4480560"/>
+            <a:off x="640080" y="4462272"/>
             <a:ext cx="10881360" cy="365760"/>
           </a:xfrm>
           <a:prstGeom prst="rect">
@@ -8125,9 +8133,6 @@
           <a:bodyPr wrap="square" lIns="0" tIns="0" rIns="0" bIns="0" rtlCol="0" anchor="ctr"/>
           <a:lstStyle/>
           <a:p>
-            <a:pPr marL="0" indent="0">
-              <a:buNone/>
-            </a:pPr>
             <a:r>
               <a:rPr lang="en-US" sz="1400" b="1" dirty="0">
                 <a:solidFill>
@@ -8137,18 +8142,18 @@
                 <a:ea typeface="Arial" pitchFamily="34" charset="-122"/>
                 <a:cs typeface="Arial" pitchFamily="34" charset="-120"/>
               </a:rPr>
-              <a:t>Demo Video Link:  </a:t>
-            </a:r>
-            <a:r>
-              <a:rPr lang="en-US" sz="1400" i="1" dirty="0">
-                <a:solidFill>
-                  <a:srgbClr val="5A5A5A"/>
-                </a:solidFill>
-                <a:latin typeface="Arial" pitchFamily="34" charset="0"/>
-                <a:ea typeface="Arial" pitchFamily="34" charset="-122"/>
-                <a:cs typeface="Arial" pitchFamily="34" charset="-120"/>
-              </a:rPr>
-              <a:t>[Add your demo link here]</a:t>
+              <a:t>Demo Video Link: </a:t>
+            </a:r>
+            <a:r>
+              <a:rPr lang="en-US" sz="1400" dirty="0">
+                <a:solidFill>
+                  <a:srgbClr val="1A1A1A"/>
+                </a:solidFill>
+                <a:latin typeface="Arial" pitchFamily="34" charset="0"/>
+                <a:ea typeface="Arial" pitchFamily="34" charset="-122"/>
+                <a:cs typeface="Arial" pitchFamily="34" charset="-120"/>
+              </a:rPr>
+              <a:t>https://youtu.be/Up5L2xeT9Qs?si=ljazp9moHquukmZA</a:t>
             </a:r>
             <a:endParaRPr lang="en-US" sz="1400" dirty="0"/>
           </a:p>

</xml_diff>